<commit_message>
lecture: rework guest lecture deck - review fixes, Haas course framing, tuning pass, full-width diagrams (WS 2026/27, ~13 min walkthrough, hard stop 16:00)
</commit_message>
<xml_diff>
--- a/lecture/agentic-ai-for-lead-generation.pptx
+++ b/lecture/agentic-ai-for-lead-generation.pptx
@@ -524,7 +524,8 @@
 (45 s) Welcome. What this lecture is: what agentic AI is, and how
 to operate it through a harness. Everything we do maps to one real
 task: helping the chair find and qualify B2B partner companies.
-The output of this session is the input for the Bachelor seminar.</a:t>
+The results feed the Bachelor course "Sales Strategy and Execution" —
+next summer semester, the chair decides what and how much to take up.</a:t>
             </a:r>
             <a:endParaRPr lang="en-US" dirty="0"/>
           </a:p>
@@ -614,7 +615,8 @@
               <a:rPr lang="en-US" dirty="0"/>
               <a:t>notes:
 (30 s) Frame the demo: no hands-on today, a walkthrough instead. The
-task is the same one the Bachelor seminar will pick up. We watch the
+task mirrors the one the Bachelor course "Sales Strategy and Execution"
+may pick up next summer semester. We watch the
 harness do steps 2-5 live; I narrate what happens and why.</a:t>
             </a:r>
             <a:endParaRPr lang="en-US" dirty="0"/>
@@ -707,7 +709,10 @@
 (2 min) Show the contract as the first artifact — the live file is
 lecture/demo/AGENTS.md in this repo. The students see that "prompting"
 an agent starts with writing rules, not typing a question. Full demo
-narration + kickoff prompt: lecture/demo/demo-script.md.</a:t>
+narration + kickoff prompt: lecture/demo/demo-script.md.
+Critical-literacy beat: every source the contract lists — company
+sites, press, registries — is self-reported or promotional. A URL
+proves a claim EXISTS, not that it is TRUE. Ask: whose evidence?</a:t>
             </a:r>
             <a:endParaRPr lang="en-US" dirty="0"/>
           </a:p>
@@ -796,7 +801,9 @@
             <a:r>
               <a:rPr lang="en-US" dirty="0"/>
               <a:t>notes:
-(8 min) THE core demo. Run the analysis loop live in pi. Narrate:
+(8 min) THE core demo — part of the ~13 min walkthrough block
+(slides 10–13; full narration timeline in demo/demo-script.md).
+Run the analysis loop live in pi. Narrate:
 (1) it opens the browser via MCP/BrowserMCP, searches for prospect
 companies; (2) it reads real pages and extracts fit signals; (3) it
 scores against the contract; (4) it writes a markdown table with URLs;
@@ -805,7 +812,9 @@
 students map what they see to the six boxes. Strategy: use a small
 real example (2-3 companies, one industry) — speed beats completeness.
 Show a mistake on purpose if possible: pause, let the agent correct —
-that IS the "loop".</a:t>
+that IS the "loop". One line on data handling: the demo runs on real,
+public company data through a cloud API — fine here; never paste
+private or customer data into a commercial harness.</a:t>
             </a:r>
             <a:endParaRPr lang="en-US" dirty="0"/>
           </a:p>
@@ -896,7 +905,11 @@
               <a:t>notes:
 (2 min) Apply the three-question bar to the just-seen output. If it
 passes, it is a deliverable; if not, it is a draft. This turns the
-demo result into the artefact the Bachelor seminar receives.</a:t>
+demo result into the artefact a Bachelor course can build on next summer semester.
+Repeatability is process-level, not byte-identical output — the model
+is stochastic; the method is re-runnable and auditable. And "citable"
+means the URL resolves AND supports the sentence. Sales connection:
+you verify a prospect's claims before you sign — same discipline here.</a:t>
             </a:r>
             <a:endParaRPr lang="en-US" dirty="0"/>
           </a:p>
@@ -1168,18 +1181,14 @@
             <a:r>
               <a:rPr lang="en-US" dirty="0"/>
               <a:t>notes:
-(1.5 min) Practical slide — what students can use NOW. Lead with the
-JLU HRZ API-Service: LLM endpoints for all JLU members, open-source
-(qwen3-coder-next 256K, qwen3.8-27b 1M) and commercial models; access
-by emailing ki@uni-giessen.de; configured in OpenCode via LiteLLM
-provider block (baseURL api.hrz.uni-giessen.de) or Claude Code via
-ANTHROPIC_BASE_URL. Google row: 12-month free Google AI Plus for
-eligible students, verify via SheerID, redeem by Dec 31 2026.
-OpenRouter: one key for many vendors, free models and pay-as-you-go
-(no subscription) — good if they want a specific commercial model
-without per-vendor signups. Ollama = local + free + private.
-Harnesses: OpenCode (first-class with HRZ API + OpenRouter) and pi are
-what the walkthrough just used.</a:t>
+(1.25 min) Practical slide — what students can use NOW. Lead with the
+JLU HRZ API-Service: free LLM endpoints for all JLU members (Qwen
+256K–1M ctx + commercial); access via ki@uni-giessen.de; OpenCode via
+LiteLLM (baseURL api.hrz.uni-giessen.de) or Claude Code via
+ANTHROPIC_BASE_URL. Google: 12 months free AI Plus, verify via
+SheerID, redeem by Dec 31 2026. OpenRouter: one key, many models,
+pay-as-you-go. Ollama: local + free + private. Harnesses: OpenCode and
+pi are what the walkthrough just used.</a:t>
             </a:r>
             <a:endParaRPr lang="en-US" dirty="0"/>
           </a:p>
@@ -1269,8 +1278,10 @@
               <a:rPr lang="en-US" dirty="0"/>
               <a:t>notes:
 (1 min) Recap the four take-aways. Close the loop: the artefact —
-the ranked shortlist — is the handover point to the Bachelor
-seminar. That is the "output as input" promise from the title slide.</a:t>
+the ranked shortlist — is the evidence base for the Bachelor course
+"Sales Strategy and Execution" next summer semester; the chair decides
+what and how much to use. That is the "output as input" promise from
+the title slide.</a:t>
             </a:r>
             <a:endParaRPr lang="en-US" dirty="0"/>
           </a:p>
@@ -1460,7 +1471,12 @@
 Likely questions: model choice (harness is model-agnostic; pi switches
 model with Ctrl+L), costs (cheap models + tight contracts), data
 privacy (local models), what "qualified" means (the contract), and how
-to try it themselves (resources slide).</a:t>
+to try it themselves (resources slide).
+If asked about non-determinism: repeatability is process-level —
+same contract → same method → auditable, re-runnable result; output
+is never guaranteed byte-identical with a stochastic model.
+Hard stop at 16:00: the course's Übung starts in the same room right
+after — never overrun Q&amp;A; the ten minutes belong to the students.</a:t>
             </a:r>
             <a:endParaRPr lang="en-US" dirty="0"/>
           </a:p>
@@ -1549,10 +1565,14 @@
             <a:r>
               <a:rPr lang="en-US" dirty="0"/>
               <a:t>notes:
-(45 s) Concrete goal for the students: by the end you can RECOGNISE
-and judge an agentic workflow — and read the contract that drives it.
+(45 s) Bridge from the preceding part first: you just heard about
+modern marketing &amp; sales in a digital world — agentic AI is the tooling
+that operationalises exactly that. Then set the concrete goal: by the
+end you can RECOGNISE and judge an agentic workflow — and read the
+contract that drives it.
 The artefact shown in the walkthrough (a ranked lead list with sources)
-becomes the working dataset the Bachelor students build on.</a:t>
+becomes evidence the Bachelor course "Sales Strategy and Execution"
+may build on next summer semester.</a:t>
             </a:r>
             <a:endParaRPr lang="en-US" dirty="0"/>
           </a:p>
@@ -1922,7 +1942,9 @@
 (2.5 min) Keep it simple. The model is the part students already know.
 The harness is the missing piece this lecture adds: an executable
 environment (terminal, browser, files) + permissions + memory.
-The loop is what makes it "agentic": it iterates, checks, corrects.</a:t>
+The loop is what makes it "agentic": it iterates, checks, corrects.
+Why pi as my default today: smaller memory footprint — the honest
+reason, not because the other harnesses are worse.</a:t>
             </a:r>
             <a:endParaRPr lang="en-US" dirty="0"/>
           </a:p>
@@ -2011,12 +2033,14 @@
             <a:r>
               <a:rPr lang="en-US" dirty="0"/>
               <a:t>notes:
-(2 min) Ground the hype in data from the chair's own open research
-corpus (marketing-research, public on GitHub). Agentic papers exist,
-lead-gen papers exist, but the intersection is literally ZERO. Say
-that number out loud — it lands harder than "nearly nobody": a
-research gap AND a practical opportunity. 2026 alone produced 7,771
-of the 13,096 papers.</a:t>
+(1.5 min) Ground the hype in data from the chair's own open corpus
+(marketing-research, public on GitHub). Agentic papers exist, lead-gen
+papers exist, but the intersection is literally ZERO — say that number
+out loud: a research gap AND a practical opportunity. 2026 alone
+produced 7,771 of the 13,096 papers. Method note for Q&amp;A: literal
+keyword matches on title+abstract — papers about "AI agents" or
+"prospecting" without the word "agentic" are not counted, and ~390
+entries have no abstract, so the counts are conservative lower bounds.</a:t>
             </a:r>
             <a:endParaRPr lang="en-US" dirty="0"/>
           </a:p>
@@ -2200,9 +2224,10 @@
 (3 min) Walk the diagram left to right: DEFINE (human, blue) → SOURCE
 → QUALIFY → RECORD → VERIFY → OUTPUT (human, green). The agent runs
 the middle four; the human sets criteria and judges the result. The
-amber feedback line: learned data tightens the next iteration's
-criteria. This exact pipeline is what the walkthrough demonstrates
-live in the next block.</a:t>
+amber feedback line: what you learn from a run updates the contract —
+you edit the criteria before the next run; the agent stays inside the
+loop, the human stays in charge. This exact pipeline is what the
+walkthrough demonstrates live in the next block.</a:t>
             </a:r>
             <a:endParaRPr lang="en-US" dirty="0"/>
           </a:p>

</xml_diff>

<commit_message>
lecture: footer - Tobias Weiß instead of WS 2026/27 · 45 min; slide 12 demo-fallback note
</commit_message>
<xml_diff>
--- a/lecture/agentic-ai-for-lead-generation.pptx
+++ b/lecture/agentic-ai-for-lead-generation.pptx
@@ -814,7 +814,10 @@
 Show a mistake on purpose if possible: pause, let the agent correct —
 that IS the "loop". One line on data handling: the demo runs on real,
 public company data through a cloud API — fine here; never paste
-private or customer data into a commercial harness.</a:t>
+private or customer data into a commercial harness.
+Fallback: if the run fails (network/API/browser), show the untouched
+recording of the same contract run (fallback-demo.mp4) and narrate over
+it — full procedure in demo/demo-script.md.</a:t>
             </a:r>
             <a:endParaRPr lang="en-US" dirty="0"/>
           </a:p>

</xml_diff>

<commit_message>
lecture: name the running model in Q&A notes (big pickle)
</commit_message>
<xml_diff>
--- a/lecture/agentic-ai-for-lead-generation.pptx
+++ b/lecture/agentic-ai-for-lead-generation.pptx
@@ -1471,8 +1471,9 @@
               <a:rPr lang="en-US" dirty="0"/>
               <a:t>notes:
 (10 min) Q&amp;A + apply the three questions to the walkthrough result.
-Likely questions: model choice (harness is model-agnostic; pi switches
-model with Ctrl+L), costs (cheap models + tight contracts), data
+Likely questions: model choice (the demo runs on **big pickle**; the
+harness is model-agnostic — pi switches model with Ctrl+L), costs (cheap
+models + tight contracts), data
 privacy (local models), what "qualified" means (the contract), and how
 to try it themselves (resources slide).
 If asked about non-determinism: repeatability is process-level —

</xml_diff>

<commit_message>
lecture: choose mechanical & plant engineering as demo sector (playbook + slide 10, updated kickoff prompts)
</commit_message>
<xml_diff>
--- a/lecture/agentic-ai-for-lead-generation.pptx
+++ b/lecture/agentic-ai-for-lead-generation.pptx
@@ -24,9 +24,10 @@
     <p:sldId id="272" r:id="rId18"/>
     <p:sldId id="273" r:id="rId19"/>
     <p:sldId id="274" r:id="rId20"/>
+    <p:sldId id="275" r:id="rId21"/>
   </p:sldIdLst>
   <p:notesMasterIdLst>
-    <p:notesMasterId r:id="rId21"/>
+    <p:notesMasterId r:id="rId22"/>
   </p:notesMasterIdLst>
   <p:sldSz cx="12192000" cy="6858000"/>
   <p:notesSz cx="6858000" cy="12192000"/>
@@ -614,6 +615,102 @@
             <a:r>
               <a:rPr lang="en-US" dirty="0"/>
               <a:t>notes:
+(45 s) Before the agent acts, a human decides the hunting ground — the
+DEFINE box, made concrete. Five criteria, scored 1–5, one hard guard.
+Our first default — grocery retail — failed the guard: lead generation
+there is a B2C, demand-gen game, not a sales-strategy one. Optics came
+close; mechanical &amp; plant engineering wins on every axis. This is the
+sector you are about to see in the demo.
+Sales-strategy beat: choosing target segments is a core sales-strategy
+decision — a method the Bachelor course can lift next summer semester.</a:t>
+            </a:r>
+            <a:endParaRPr lang="en-US" dirty="0"/>
+          </a:p>
+        </p:txBody>
+      </p:sp>
+      <p:sp>
+        <p:nvSpPr>
+          <p:cNvPr id="4" name="Slide Number Placeholder 3"/>
+          <p:cNvSpPr>
+            <a:spLocks noGrp="1"/>
+          </p:cNvSpPr>
+          <p:nvPr>
+            <p:ph type="sldNum" sz="quarter" idx="10"/>
+          </p:nvPr>
+        </p:nvSpPr>
+        <p:spPr/>
+        <p:txBody>
+          <a:bodyPr/>
+          <a:lstStyle/>
+          <a:p>
+            <a:fld id="{F7021451-1387-4CA6-816F-3879F97B5CBC}" type="slidenum">
+              <a:rPr lang="en-US"/>
+              <a:t>10</a:t>
+            </a:fld>
+            <a:endParaRPr lang="en-US"/>
+          </a:p>
+        </p:txBody>
+      </p:sp>
+    </p:spTree>
+    <p:extLst>
+      <p:ext uri="{BB962C8B-B14F-4D97-AF65-F5344CB8AC3E}">
+        <p14:creationId xmlns:p14="http://schemas.microsoft.com/office/powerpoint/2010/main" val="1024086991"/>
+      </p:ext>
+    </p:extLst>
+  </p:cSld>
+  <p:clrMapOvr>
+    <a:masterClrMapping/>
+  </p:clrMapOvr>
+</p:notes>
+</file>
+
+<file path=ppt/notesSlides/notesSlide11.xml><?xml version="1.0" encoding="utf-8"?>
+<p:notes xmlns:a="http://schemas.openxmlformats.org/drawingml/2006/main" xmlns:r="http://schemas.openxmlformats.org/officeDocument/2006/relationships" xmlns:p="http://schemas.openxmlformats.org/presentationml/2006/main">
+  <p:cSld>
+    <p:spTree>
+      <p:nvGrpSpPr>
+        <p:cNvPr id="1" name=""/>
+        <p:cNvGrpSpPr/>
+        <p:nvPr/>
+      </p:nvGrpSpPr>
+      <p:grpSpPr>
+        <a:xfrm>
+          <a:off x="0" y="0"/>
+          <a:ext cx="0" cy="0"/>
+          <a:chOff x="0" y="0"/>
+          <a:chExt cx="0" cy="0"/>
+        </a:xfrm>
+      </p:grpSpPr>
+      <p:sp>
+        <p:nvSpPr>
+          <p:cNvPr id="2" name="Slide Image Placeholder 1"/>
+          <p:cNvSpPr>
+            <a:spLocks noGrp="1" noRot="1" noChangeAspect="1"/>
+          </p:cNvSpPr>
+          <p:nvPr>
+            <p:ph type="sldImg"/>
+          </p:nvPr>
+        </p:nvSpPr>
+        <p:spPr/>
+      </p:sp>
+      <p:sp>
+        <p:nvSpPr>
+          <p:cNvPr id="3" name="Notes Placeholder 2"/>
+          <p:cNvSpPr>
+            <a:spLocks noGrp="1"/>
+          </p:cNvSpPr>
+          <p:nvPr>
+            <p:ph type="body" idx="1"/>
+          </p:nvPr>
+        </p:nvSpPr>
+        <p:spPr/>
+        <p:txBody>
+          <a:bodyPr/>
+          <a:lstStyle/>
+          <a:p>
+            <a:r>
+              <a:rPr lang="en-US" dirty="0"/>
+              <a:t>notes:
 (30 s) Frame the demo: no hands-on today, a walkthrough instead. The
 task mirrors the one the Bachelor course "Sales Strategy and Execution"
 may pick up next summer semester. We watch the
@@ -640,7 +737,7 @@
           <a:p>
             <a:fld id="{F7021451-1387-4CA6-816F-3879F97B5CBC}" type="slidenum">
               <a:rPr lang="en-US"/>
-              <a:t>10</a:t>
+              <a:t>11</a:t>
             </a:fld>
             <a:endParaRPr lang="en-US"/>
           </a:p>
@@ -659,7 +756,7 @@
 </p:notes>
 </file>
 
-<file path=ppt/notesSlides/notesSlide11.xml><?xml version="1.0" encoding="utf-8"?>
+<file path=ppt/notesSlides/notesSlide12.xml><?xml version="1.0" encoding="utf-8"?>
 <p:notes xmlns:a="http://schemas.openxmlformats.org/drawingml/2006/main" xmlns:r="http://schemas.openxmlformats.org/officeDocument/2006/relationships" xmlns:p="http://schemas.openxmlformats.org/presentationml/2006/main">
   <p:cSld>
     <p:spTree>
@@ -735,7 +832,7 @@
           <a:p>
             <a:fld id="{F7021451-1387-4CA6-816F-3879F97B5CBC}" type="slidenum">
               <a:rPr lang="en-US"/>
-              <a:t>11</a:t>
+              <a:t>12</a:t>
             </a:fld>
             <a:endParaRPr lang="en-US"/>
           </a:p>
@@ -754,7 +851,7 @@
 </p:notes>
 </file>
 
-<file path=ppt/notesSlides/notesSlide12.xml><?xml version="1.0" encoding="utf-8"?>
+<file path=ppt/notesSlides/notesSlide13.xml><?xml version="1.0" encoding="utf-8"?>
 <p:notes xmlns:a="http://schemas.openxmlformats.org/drawingml/2006/main" xmlns:r="http://schemas.openxmlformats.org/officeDocument/2006/relationships" xmlns:p="http://schemas.openxmlformats.org/presentationml/2006/main">
   <p:cSld>
     <p:spTree>
@@ -802,7 +899,7 @@
               <a:rPr lang="en-US" dirty="0"/>
               <a:t>notes:
 (8 min) THE core demo — part of the ~13 min walkthrough block
-(slides 10–13; full narration timeline in demo/demo-script.md).
+(slides 11–14; full narration timeline in demo/demo-script.md).
 Run the analysis loop live in pi. Narrate:
 (1) it opens the browser via MCP/BrowserMCP, searches for prospect
 companies; (2) it reads real pages and extracts fit signals; (3) it
@@ -840,7 +937,7 @@
           <a:p>
             <a:fld id="{F7021451-1387-4CA6-816F-3879F97B5CBC}" type="slidenum">
               <a:rPr lang="en-US"/>
-              <a:t>12</a:t>
+              <a:t>13</a:t>
             </a:fld>
             <a:endParaRPr lang="en-US"/>
           </a:p>
@@ -859,7 +956,7 @@
 </p:notes>
 </file>
 
-<file path=ppt/notesSlides/notesSlide13.xml><?xml version="1.0" encoding="utf-8"?>
+<file path=ppt/notesSlides/notesSlide14.xml><?xml version="1.0" encoding="utf-8"?>
 <p:notes xmlns:a="http://schemas.openxmlformats.org/drawingml/2006/main" xmlns:r="http://schemas.openxmlformats.org/officeDocument/2006/relationships" xmlns:p="http://schemas.openxmlformats.org/presentationml/2006/main">
   <p:cSld>
     <p:spTree>
@@ -935,7 +1032,7 @@
           <a:p>
             <a:fld id="{F7021451-1387-4CA6-816F-3879F97B5CBC}" type="slidenum">
               <a:rPr lang="en-US"/>
-              <a:t>13</a:t>
+              <a:t>14</a:t>
             </a:fld>
             <a:endParaRPr lang="en-US"/>
           </a:p>
@@ -954,7 +1051,7 @@
 </p:notes>
 </file>
 
-<file path=ppt/notesSlides/notesSlide14.xml><?xml version="1.0" encoding="utf-8"?>
+<file path=ppt/notesSlides/notesSlide15.xml><?xml version="1.0" encoding="utf-8"?>
 <p:notes xmlns:a="http://schemas.openxmlformats.org/drawingml/2006/main" xmlns:r="http://schemas.openxmlformats.org/officeDocument/2006/relationships" xmlns:p="http://schemas.openxmlformats.org/presentationml/2006/main">
   <p:cSld>
     <p:spTree>
@@ -1027,7 +1124,7 @@
           <a:p>
             <a:fld id="{F7021451-1387-4CA6-816F-3879F97B5CBC}" type="slidenum">
               <a:rPr lang="en-US"/>
-              <a:t>14</a:t>
+              <a:t>15</a:t>
             </a:fld>
             <a:endParaRPr lang="en-US"/>
           </a:p>
@@ -1046,7 +1143,7 @@
 </p:notes>
 </file>
 
-<file path=ppt/notesSlides/notesSlide15.xml><?xml version="1.0" encoding="utf-8"?>
+<file path=ppt/notesSlides/notesSlide16.xml><?xml version="1.0" encoding="utf-8"?>
 <p:notes xmlns:a="http://schemas.openxmlformats.org/drawingml/2006/main" xmlns:r="http://schemas.openxmlformats.org/officeDocument/2006/relationships" xmlns:p="http://schemas.openxmlformats.org/presentationml/2006/main">
   <p:cSld>
     <p:spTree>
@@ -1118,7 +1215,7 @@
           <a:p>
             <a:fld id="{F7021451-1387-4CA6-816F-3879F97B5CBC}" type="slidenum">
               <a:rPr lang="en-US"/>
-              <a:t>15</a:t>
+              <a:t>16</a:t>
             </a:fld>
             <a:endParaRPr lang="en-US"/>
           </a:p>
@@ -1137,7 +1234,7 @@
 </p:notes>
 </file>
 
-<file path=ppt/notesSlides/notesSlide16.xml><?xml version="1.0" encoding="utf-8"?>
+<file path=ppt/notesSlides/notesSlide17.xml><?xml version="1.0" encoding="utf-8"?>
 <p:notes xmlns:a="http://schemas.openxmlformats.org/drawingml/2006/main" xmlns:r="http://schemas.openxmlformats.org/officeDocument/2006/relationships" xmlns:p="http://schemas.openxmlformats.org/presentationml/2006/main">
   <p:cSld>
     <p:spTree>
@@ -1214,7 +1311,7 @@
           <a:p>
             <a:fld id="{F7021451-1387-4CA6-816F-3879F97B5CBC}" type="slidenum">
               <a:rPr lang="en-US"/>
-              <a:t>16</a:t>
+              <a:t>17</a:t>
             </a:fld>
             <a:endParaRPr lang="en-US"/>
           </a:p>
@@ -1233,7 +1330,7 @@
 </p:notes>
 </file>
 
-<file path=ppt/notesSlides/notesSlide17.xml><?xml version="1.0" encoding="utf-8"?>
+<file path=ppt/notesSlides/notesSlide18.xml><?xml version="1.0" encoding="utf-8"?>
 <p:notes xmlns:a="http://schemas.openxmlformats.org/drawingml/2006/main" xmlns:r="http://schemas.openxmlformats.org/officeDocument/2006/relationships" xmlns:p="http://schemas.openxmlformats.org/presentationml/2006/main">
   <p:cSld>
     <p:spTree>
@@ -1307,7 +1404,7 @@
           <a:p>
             <a:fld id="{F7021451-1387-4CA6-816F-3879F97B5CBC}" type="slidenum">
               <a:rPr lang="en-US"/>
-              <a:t>17</a:t>
+              <a:t>18</a:t>
             </a:fld>
             <a:endParaRPr lang="en-US"/>
           </a:p>
@@ -1326,7 +1423,7 @@
 </p:notes>
 </file>
 
-<file path=ppt/notesSlides/notesSlide18.xml><?xml version="1.0" encoding="utf-8"?>
+<file path=ppt/notesSlides/notesSlide19.xml><?xml version="1.0" encoding="utf-8"?>
 <p:notes xmlns:a="http://schemas.openxmlformats.org/drawingml/2006/main" xmlns:r="http://schemas.openxmlformats.org/officeDocument/2006/relationships" xmlns:p="http://schemas.openxmlformats.org/presentationml/2006/main">
   <p:cSld>
     <p:spTree>
@@ -1404,7 +1501,7 @@
           <a:p>
             <a:fld id="{F7021451-1387-4CA6-816F-3879F97B5CBC}" type="slidenum">
               <a:rPr lang="en-US"/>
-              <a:t>18</a:t>
+              <a:t>19</a:t>
             </a:fld>
             <a:endParaRPr lang="en-US"/>
           </a:p>
@@ -1423,7 +1520,103 @@
 </p:notes>
 </file>
 
-<file path=ppt/notesSlides/notesSlide19.xml><?xml version="1.0" encoding="utf-8"?>
+<file path=ppt/notesSlides/notesSlide2.xml><?xml version="1.0" encoding="utf-8"?>
+<p:notes xmlns:a="http://schemas.openxmlformats.org/drawingml/2006/main" xmlns:r="http://schemas.openxmlformats.org/officeDocument/2006/relationships" xmlns:p="http://schemas.openxmlformats.org/presentationml/2006/main">
+  <p:cSld>
+    <p:spTree>
+      <p:nvGrpSpPr>
+        <p:cNvPr id="1" name=""/>
+        <p:cNvGrpSpPr/>
+        <p:nvPr/>
+      </p:nvGrpSpPr>
+      <p:grpSpPr>
+        <a:xfrm>
+          <a:off x="0" y="0"/>
+          <a:ext cx="0" cy="0"/>
+          <a:chOff x="0" y="0"/>
+          <a:chExt cx="0" cy="0"/>
+        </a:xfrm>
+      </p:grpSpPr>
+      <p:sp>
+        <p:nvSpPr>
+          <p:cNvPr id="2" name="Slide Image Placeholder 1"/>
+          <p:cNvSpPr>
+            <a:spLocks noGrp="1" noRot="1" noChangeAspect="1"/>
+          </p:cNvSpPr>
+          <p:nvPr>
+            <p:ph type="sldImg"/>
+          </p:nvPr>
+        </p:nvSpPr>
+        <p:spPr/>
+      </p:sp>
+      <p:sp>
+        <p:nvSpPr>
+          <p:cNvPr id="3" name="Notes Placeholder 2"/>
+          <p:cNvSpPr>
+            <a:spLocks noGrp="1"/>
+          </p:cNvSpPr>
+          <p:nvPr>
+            <p:ph type="body" idx="1"/>
+          </p:nvPr>
+        </p:nvSpPr>
+        <p:spPr/>
+        <p:txBody>
+          <a:bodyPr/>
+          <a:lstStyle/>
+          <a:p>
+            <a:r>
+              <a:rPr lang="en-US" dirty="0"/>
+              <a:t>notes:
+(45 s) Bridge from the preceding part first: you just heard about
+modern marketing &amp; sales in a digital world — agentic AI is the tooling
+that operationalises exactly that. Then set the concrete goal: by the
+end you can RECOGNISE and judge an agentic workflow — and read the
+contract that drives it.
+The artefact shown in the walkthrough (a ranked lead list with sources)
+becomes evidence the Bachelor course "Sales Strategy and Execution"
+may build on next summer semester.</a:t>
+            </a:r>
+            <a:endParaRPr lang="en-US" dirty="0"/>
+          </a:p>
+        </p:txBody>
+      </p:sp>
+      <p:sp>
+        <p:nvSpPr>
+          <p:cNvPr id="4" name="Slide Number Placeholder 3"/>
+          <p:cNvSpPr>
+            <a:spLocks noGrp="1"/>
+          </p:cNvSpPr>
+          <p:nvPr>
+            <p:ph type="sldNum" sz="quarter" idx="10"/>
+          </p:nvPr>
+        </p:nvSpPr>
+        <p:spPr/>
+        <p:txBody>
+          <a:bodyPr/>
+          <a:lstStyle/>
+          <a:p>
+            <a:fld id="{F7021451-1387-4CA6-816F-3879F97B5CBC}" type="slidenum">
+              <a:rPr lang="en-US"/>
+              <a:t>2</a:t>
+            </a:fld>
+            <a:endParaRPr lang="en-US"/>
+          </a:p>
+        </p:txBody>
+      </p:sp>
+    </p:spTree>
+    <p:extLst>
+      <p:ext uri="{BB962C8B-B14F-4D97-AF65-F5344CB8AC3E}">
+        <p14:creationId xmlns:p14="http://schemas.microsoft.com/office/powerpoint/2010/main" val="1024086991"/>
+      </p:ext>
+    </p:extLst>
+  </p:cSld>
+  <p:clrMapOvr>
+    <a:masterClrMapping/>
+  </p:clrMapOvr>
+</p:notes>
+</file>
+
+<file path=ppt/notesSlides/notesSlide20.xml><?xml version="1.0" encoding="utf-8"?>
 <p:notes xmlns:a="http://schemas.openxmlformats.org/drawingml/2006/main" xmlns:r="http://schemas.openxmlformats.org/officeDocument/2006/relationships" xmlns:p="http://schemas.openxmlformats.org/presentationml/2006/main">
   <p:cSld>
     <p:spTree>
@@ -1503,103 +1696,7 @@
           <a:p>
             <a:fld id="{F7021451-1387-4CA6-816F-3879F97B5CBC}" type="slidenum">
               <a:rPr lang="en-US"/>
-              <a:t>19</a:t>
-            </a:fld>
-            <a:endParaRPr lang="en-US"/>
-          </a:p>
-        </p:txBody>
-      </p:sp>
-    </p:spTree>
-    <p:extLst>
-      <p:ext uri="{BB962C8B-B14F-4D97-AF65-F5344CB8AC3E}">
-        <p14:creationId xmlns:p14="http://schemas.microsoft.com/office/powerpoint/2010/main" val="1024086991"/>
-      </p:ext>
-    </p:extLst>
-  </p:cSld>
-  <p:clrMapOvr>
-    <a:masterClrMapping/>
-  </p:clrMapOvr>
-</p:notes>
-</file>
-
-<file path=ppt/notesSlides/notesSlide2.xml><?xml version="1.0" encoding="utf-8"?>
-<p:notes xmlns:a="http://schemas.openxmlformats.org/drawingml/2006/main" xmlns:r="http://schemas.openxmlformats.org/officeDocument/2006/relationships" xmlns:p="http://schemas.openxmlformats.org/presentationml/2006/main">
-  <p:cSld>
-    <p:spTree>
-      <p:nvGrpSpPr>
-        <p:cNvPr id="1" name=""/>
-        <p:cNvGrpSpPr/>
-        <p:nvPr/>
-      </p:nvGrpSpPr>
-      <p:grpSpPr>
-        <a:xfrm>
-          <a:off x="0" y="0"/>
-          <a:ext cx="0" cy="0"/>
-          <a:chOff x="0" y="0"/>
-          <a:chExt cx="0" cy="0"/>
-        </a:xfrm>
-      </p:grpSpPr>
-      <p:sp>
-        <p:nvSpPr>
-          <p:cNvPr id="2" name="Slide Image Placeholder 1"/>
-          <p:cNvSpPr>
-            <a:spLocks noGrp="1" noRot="1" noChangeAspect="1"/>
-          </p:cNvSpPr>
-          <p:nvPr>
-            <p:ph type="sldImg"/>
-          </p:nvPr>
-        </p:nvSpPr>
-        <p:spPr/>
-      </p:sp>
-      <p:sp>
-        <p:nvSpPr>
-          <p:cNvPr id="3" name="Notes Placeholder 2"/>
-          <p:cNvSpPr>
-            <a:spLocks noGrp="1"/>
-          </p:cNvSpPr>
-          <p:nvPr>
-            <p:ph type="body" idx="1"/>
-          </p:nvPr>
-        </p:nvSpPr>
-        <p:spPr/>
-        <p:txBody>
-          <a:bodyPr/>
-          <a:lstStyle/>
-          <a:p>
-            <a:r>
-              <a:rPr lang="en-US" dirty="0"/>
-              <a:t>notes:
-(45 s) Bridge from the preceding part first: you just heard about
-modern marketing &amp; sales in a digital world — agentic AI is the tooling
-that operationalises exactly that. Then set the concrete goal: by the
-end you can RECOGNISE and judge an agentic workflow — and read the
-contract that drives it.
-The artefact shown in the walkthrough (a ranked lead list with sources)
-becomes evidence the Bachelor course "Sales Strategy and Execution"
-may build on next summer semester.</a:t>
-            </a:r>
-            <a:endParaRPr lang="en-US" dirty="0"/>
-          </a:p>
-        </p:txBody>
-      </p:sp>
-      <p:sp>
-        <p:nvSpPr>
-          <p:cNvPr id="4" name="Slide Number Placeholder 3"/>
-          <p:cNvSpPr>
-            <a:spLocks noGrp="1"/>
-          </p:cNvSpPr>
-          <p:nvPr>
-            <p:ph type="sldNum" sz="quarter" idx="10"/>
-          </p:nvPr>
-        </p:nvSpPr>
-        <p:spPr/>
-        <p:txBody>
-          <a:bodyPr/>
-          <a:lstStyle/>
-          <a:p>
-            <a:fld id="{F7021451-1387-4CA6-816F-3879F97B5CBC}" type="slidenum">
-              <a:rPr lang="en-US"/>
-              <a:t>2</a:t>
+              <a:t>20</a:t>
             </a:fld>
             <a:endParaRPr lang="en-US"/>
           </a:p>
@@ -2231,7 +2328,8 @@
 amber feedback line: what you learn from a run updates the contract —
 you edit the criteria before the next run; the agent stays inside the
 loop, the human stays in charge. This exact pipeline is what the
-walkthrough demonstrates live in the next block.</a:t>
+walkthrough demonstrates live in the next block. The next slide makes
+DEFINE concrete: the sector choice — still human work.</a:t>
             </a:r>
             <a:endParaRPr lang="en-US" dirty="0"/>
           </a:p>
@@ -3012,6 +3110,45 @@
 <file path=ppt/slides/slide2.xml><?xml version="1.0" encoding="utf-8"?>
 <p:sld xmlns:a="http://schemas.openxmlformats.org/drawingml/2006/main" xmlns:r="http://schemas.openxmlformats.org/officeDocument/2006/relationships" xmlns:p="http://schemas.openxmlformats.org/presentationml/2006/main">
   <p:cSld name="Slide 2">
+    <p:bg>
+      <p:bgPr>
+        <a:blipFill dpi="0" rotWithShape="1">
+          <a:blip r:embed="rId1">
+            <a:lum/>
+          </a:blip>
+          <a:srcRect/>
+          <a:stretch>
+            <a:fillRect/>
+          </a:stretch>
+        </a:blipFill>
+        <a:effectLst/>
+      </p:bgPr>
+    </p:bg>
+    <p:spTree>
+      <p:nvGrpSpPr>
+        <p:cNvPr id="1" name=""/>
+        <p:cNvGrpSpPr/>
+        <p:nvPr/>
+      </p:nvGrpSpPr>
+      <p:grpSpPr>
+        <a:xfrm>
+          <a:off x="0" y="0"/>
+          <a:ext cx="0" cy="0"/>
+          <a:chOff x="0" y="0"/>
+          <a:chExt cx="0" cy="0"/>
+        </a:xfrm>
+      </p:grpSpPr>
+    </p:spTree>
+  </p:cSld>
+  <p:clrMapOvr>
+    <a:masterClrMapping/>
+  </p:clrMapOvr>
+</p:sld>
+</file>
+
+<file path=ppt/slides/slide20.xml><?xml version="1.0" encoding="utf-8"?>
+<p:sld xmlns:a="http://schemas.openxmlformats.org/drawingml/2006/main" xmlns:r="http://schemas.openxmlformats.org/officeDocument/2006/relationships" xmlns:p="http://schemas.openxmlformats.org/presentationml/2006/main">
+  <p:cSld name="Slide 20">
     <p:bg>
       <p:bgPr>
         <a:blipFill dpi="0" rotWithShape="1">

</xml_diff>

<commit_message>
lecture: weave 'context' through the deck — the thread that makes the workflow trustworthy (capabilities → evidence → contract → pipeline → demo → verification → take-aways); restore hard corpus numbers on 'why now' (13,096 / 7,771 / agentic 91 / lead-gen 27 / intersection 0 / context-aware 22); fix slide 6+8 overflow; context rule in demo AGENTS.md
</commit_message>
<xml_diff>
--- a/lecture/agentic-ai-for-lead-generation.pptx
+++ b/lecture/agentic-ai-for-lead-generation.pptx
@@ -914,7 +914,10 @@
 private or customer data into a commercial harness.
 Fallback: if the run fails (network/API/browser), show the untouched
 recording of the same contract run (fallback-demo.mp4) and narrate over
-it — full procedure in demo/demo-script.md.</a:t>
+it — full procedure in demo/demo-script.md.
+Context narration beat: when the agent opens AGENTS.md, say out loud:
+"right now it is absorbing our context — the criteria it could not
+invent for itself." One sentence; it teaches the whole thread.</a:t>
             </a:r>
             <a:endParaRPr lang="en-US" dirty="0"/>
           </a:p>
@@ -1009,7 +1012,12 @@
 Repeatability is process-level, not byte-identical output — the model
 is stochastic; the method is re-runnable and auditable. And "citable"
 means the URL resolves AND supports the sentence. Sales connection:
-you verify a prospect's claims before you sign — same discipline here.</a:t>
+you verify a prospect's claims before you sign — same discipline here.
+Context framing: each question defends a different way context breaks
+— the agent inventing what it doesn't know, pointing at a source that
+isn't there, or leaving the context in someone's head so the result
+can't be re-derived. That is why the three questions are the
+scientific part, not a formality.</a:t>
             </a:r>
             <a:endParaRPr lang="en-US" dirty="0"/>
           </a:p>
@@ -1101,7 +1109,10 @@
 (1 min) Close the walkthrough: the students take away the METHOD, not
 just the result. The contract + three questions are the transferable
 part; the harness is a tool they can try themselves afterwards.
-Point to resources slide for how to start.</a:t>
+Point to resources slide for how to start.
+Item 4 is the thread made explicit for the first time: the
+walkthrough only worked because context entered via the contract and
+was held honest by the loop.</a:t>
             </a:r>
             <a:endParaRPr lang="en-US" dirty="0"/>
           </a:p>
@@ -1381,7 +1392,10 @@
 the ranked shortlist — is the evidence base for the Bachelor course
 "Sales Strategy and Execution" next summer semester; the chair decides
 what and how much to use. That is the "output as input" promise from
-the title slide.</a:t>
+the title slide.
+Take-away 5 is the one-liner to leave them with: a small model with
+your context beats a big model with none. That reframe is what makes
+this lecture's message portable beyond today's demo.</a:t>
             </a:r>
             <a:endParaRPr lang="en-US" dirty="0"/>
           </a:p>
@@ -1672,6 +1686,10 @@
 If asked about non-determinism: repeatability is process-level —
 same contract → same method → auditable, re-runnable result; output
 is never guaranteed byte-identical with a stochastic model.
+If asked "isn't this just a fancy search engine?": search returns
+matches; this returns judgements — because the contract carries the
+chair's context and every judgement is source-traceable. Context is
+the difference, and it is yours, not the model's.
 Hard stop at 16:00: the course's Übung starts in the same room right
 after — never overrun Q&amp;A; the ten minutes belong to the students.</a:t>
             </a:r>
@@ -1764,7 +1782,9 @@
               <a:t>notes:
 (30 s) Read the rows top to bottom; each becomes a section of the
 lecture. Row 4 notes there is no hands-on today — the walkthrough
-models the method; trying it yourself is the exercise afterwards.</a:t>
+models the method; trying it yourself is the exercise afterwards.
+Row 5 is the thread of the whole talk: intelligence is distributed —
+generation (model), execution (harness), context (you).</a:t>
             </a:r>
             <a:endParaRPr lang="en-US" dirty="0"/>
           </a:p>
@@ -2044,6 +2064,9 @@
 The harness is the missing piece this lecture adds: an executable
 environment (terminal, browser, files) + permissions + memory.
 The loop is what makes it "agentic": it iterates, checks, corrects.
+The fourth ingredient — context — is invisible on this diagram
+because it is yours: the criteria and judgement the loop cannot
+generate for itself. Name it here; slide 8 makes it concrete.
 Why pi as my default today: smaller memory footprint — the honest
 reason, not because the other harnesses are worse.</a:t>
             </a:r>
@@ -2134,13 +2157,16 @@
             <a:r>
               <a:rPr lang="en-US" dirty="0"/>
               <a:t>notes:
-(1.5 min) Ground the hype in data from the chair's own open corpus
-(marketing-research, public on GitHub). Agentic papers exist, lead-gen
-papers exist, but the intersection is literally ZERO — say that number
-out loud: a research gap AND a practical opportunity. Method note for Q&amp;A: literal
-keyword matches on title+abstract — papers about "AI agents" or
-"prospecting" without the word "agentic" are not counted, and ~423
-entries have no abstract, so the counts are conservative lower bounds.</a:t>
+(1.5 min) Ground the hype in the chair's own open corpus
+(marketing-research, public on GitHub). 2026 alone produced 7,771 of
+the 13,096 papers. Agentic exists (91), lead-gen exists (27) — the
+intersection is literally ZERO; say that out loud. Context-aware
+marketing is a live thread (22 papers) but it stays on attribution
+and personalization — never on the agent's working context. So the
+triple intersection is empty: that is the opening, and it is this
+chair's to fill. Honesty note: counts come from keyword search over
+title/abstract in our own corpus — a heuristic, not a citation index
+— but it is conservative; the gap is real and wide.</a:t>
             </a:r>
             <a:endParaRPr lang="en-US" dirty="0"/>
           </a:p>
@@ -2232,7 +2258,10 @@
 (2 min) The central mental model of the lecture: prompts are how you
 ask a chat; contracts are how you run an agent. A contract lives in
 the repo, is versioned, and says what done means. This is what turns
-an AI "idea generator" into a reproducible research pipeline.</a:t>
+an AI "idea generator" into a reproducible research pipeline.
+Context beat: the contract is a container for context — the chair's
+criteria, sources, judgement, partnership history. Without it the
+agent is a brilliant generalist with no idea what "good" means here.</a:t>
             </a:r>
             <a:endParaRPr lang="en-US" dirty="0"/>
           </a:p>
@@ -2328,7 +2357,11 @@
 you edit the criteria before the next run; the agent stays inside the
 loop, the human stays in charge. This exact pipeline is what the
 walkthrough demonstrates live in the next block. The next slide makes
-DEFINE concrete: the sector choice — still human work.</a:t>
+DEFINE concrete: the sector choice — still human work.
+Context mapping: DEFINE injects context (criteria, sector, guard
+rails); EVALUATE judges with context (the three questions). The amber
+line is context flowing back — what a run teaches updates the
+contract for the next run.</a:t>
             </a:r>
             <a:endParaRPr lang="en-US" dirty="0"/>
           </a:p>

</xml_diff>

<commit_message>
lecture: rewrite all speaker notes as read-aloud script (first-person spoken prose + [bracketed] cues; stage notes separated)
</commit_message>
<xml_diff>
--- a/lecture/agentic-ai-for-lead-generation.pptx
+++ b/lecture/agentic-ai-for-lead-generation.pptx
@@ -522,11 +522,15 @@
             <a:r>
               <a:rPr lang="en-US" dirty="0"/>
               <a:t>notes:
-(45 s) Welcome. What this lecture is: what agentic AI is, and how
-to operate it through a harness. Everything we do maps to one real
-task: helping the chair find and qualify B2B partner companies.
-The results feed the Bachelor course "Sales Strategy and Execution" —
-next summer semester, the chair decides what and how much to take up.</a:t>
+⏱ ~45 s · READ ALOUD
+Good afternoon — and thank you for having me. Here's what this
+session is about: agentic AI — what it is, and how you run it so
+that its work is trustworthy. And everything we do today maps onto
+one real task: helping this chair find and qualify B2B partner
+companies. The shortlist the agent produces is evidence for our
+Bachelor course Sales Strategy and Execution next summer. So
+nothing here is an exercise — it's the start of a deliverable.
+Let's get going.</a:t>
             </a:r>
             <a:endParaRPr lang="en-US" dirty="0"/>
           </a:p>
@@ -615,14 +619,16 @@
             <a:r>
               <a:rPr lang="en-US" dirty="0"/>
               <a:t>notes:
-(45 s) Before the agent acts, a human decides the hunting ground — the
-DEFINE box, made concrete. Five criteria, scored 1–5, one hard guard.
-Our first default — grocery retail — failed the guard: lead generation
-there is a B2C, demand-gen game, not a sales-strategy one. Optics came
-close; mechanical &amp; plant engineering wins on every axis. This is the
-sector you are about to see in the demo.
-Sales-strategy beat: choosing target segments is a core sales-strategy
-decision — a method the Bachelor course can lift next summer semester.</a:t>
+⏱ ~45 s · READ ALOUD
+Before the agent does anything, a human decides where to hunt.
+Look at this table: five criteria, scored one to five, and one hard
+guard. Our first default — grocery retail — fails the guard,
+because lead generation there is a consumer, demand-gen game, not a
+sales-strategy one. Optics came close. But mechanical and plant
+engineering wins on every axis. So that's the sector you're about
+to see in the demo. And notice what just happened: the AI did not
+choose the sector. We did. Choosing target segments is a core
+sales-strategy decision — one we can teach in the Bachelor course.</a:t>
             </a:r>
             <a:endParaRPr lang="en-US" dirty="0"/>
           </a:p>
@@ -711,10 +717,16 @@
             <a:r>
               <a:rPr lang="en-US" dirty="0"/>
               <a:t>notes:
-(30 s) Frame the demo: no hands-on today, a walkthrough instead. The
-task mirrors the one the Bachelor course "Sales Strategy and Execution"
-may pick up next summer semester. We watch the
-harness do steps 2-5 live; I narrate what happens and why.</a:t>
+⏱ ~30 s · READ ALOUD
+So — the live walkthrough. The task: build the partner-candidate
+shortlist, top ten B2B companies. Live today, we'll do two of them
+— the method is what matters, not the count. Each company gets a
+fit signal in one sentence, every claim carries a source URL, and
+the output is ranked. That shortlist is evidence for the Bachelor
+course next year. There's no hands-on today — this is a
+walkthrough. I run it in the harness live, and what you see is what
+the agent does. Watch what happens — and watch what doesn't happen
+on screen. Let's go.</a:t>
             </a:r>
             <a:endParaRPr lang="en-US" dirty="0"/>
           </a:p>
@@ -803,13 +815,17 @@
             <a:r>
               <a:rPr lang="en-US" dirty="0"/>
               <a:t>notes:
-(2 min) Show the contract as the first artifact — the live file is
-lecture/demo/AGENTS.md in this repo. The students see that "prompting"
-an agent starts with writing rules, not typing a question. Full demo
-narration + kickoff prompt: lecture/demo/demo-script.md.
-Critical-literacy beat: every source the contract lists — company
-sites, press, registries — is self-reported or promotional. A URL
-proves a claim EXISTS, not that it is TRUE. Ask: whose evidence?</a:t>
+⏱ ~2 min · READ ALOUD
+Step one: the contract. This is the file the agent reads every time
+it starts — and it's in this repository, you can open it yourself.
+Look at what a contract actually contains: a goal, criteria,
+sources, an output format, and rules. Now, the natural instinct is
+to think you prompt an AI by typing a question. You don't. You
+start by writing rules. And one critical-literacy point before we
+go on — because it really matters: every source this contract
+lists is self-reported by the companies themselves. A URL proves a
+claim exists; it does not prove the claim is true. So the standing
+question for everything we do today is: whose evidence is this?</a:t>
             </a:r>
             <a:endParaRPr lang="en-US" dirty="0"/>
           </a:p>
@@ -898,26 +914,26 @@
             <a:r>
               <a:rPr lang="en-US" dirty="0"/>
               <a:t>notes:
-(8 min) THE core demo — part of the ~13 min walkthrough block
-(slides 11–14; full narration timeline in demo/demo-script.md).
-Run the analysis loop live in pi. Narrate:
-(1) it opens the browser via MCP/BrowserMCP, searches for prospect
-companies; (2) it reads real pages and extracts fit signals; (3) it
-scores against the contract; (4) it writes a markdown table with URLs;
-(5) it re-checks its own citations; (6) it produces the ranked list.
-The visual loop is on the pipeline slide before — reference it so
-students map what they see to the six boxes. Strategy: use a small
-real example (2-3 companies, one industry) — speed beats completeness.
-Show a mistake on purpose if possible: pause, let the agent correct —
-that IS the "loop". One line on data handling: the demo runs on real,
-public company data through a cloud API — fine here; never paste
-private or customer data into a commercial harness.
-Fallback: if the run fails (network/API/browser), show the untouched
-recording of the same contract run (fallback-demo.mp4) and narrate over
-it — full procedure in demo/demo-script.md.
-Context narration beat: when the agent opens AGENTS.md, say out loud:
-"right now it is absorbing our context — the criteria it could not
-invent for itself." One sentence; it teaches the whole thread.</a:t>
+⏱ ~8 min live action — spoken play-by-play, in this order:
+[agent starts] "I'm introducing the agent the way I'd introduce a
+new colleague: here's the contract, here's the task — show me your
+plan first."
+[it plans] "Watch the plan — it maps one to one onto those six boxes
+from the pipeline slide."
+[it opens the browser] "There it is — it can touch the world, that's
+what agentic means. It's reading the companies' own pages. Right
+now it is absorbing our context — the criteria it could not invent
+for itself."
+[it scores] "Now it scores each company against the contract — fit
+signal, one sentence, with the source right next to it."
+[on a mistake — pause, then:] "Hold on. Did you see that? It
+over-claimed. Stop. Which URL actually says that?" [let it
+correct itself] "That pause-and-correct — that is the loop in
+action."
+[it re-checks citations] "Now it's re-checking its own citations —
+do those URLs actually resolve? That's step five: verify."
+[final table] "And there's the shortlist — ranked, cited, done.
+Let's judge it with the three questions."</a:t>
             </a:r>
             <a:endParaRPr lang="en-US" dirty="0"/>
           </a:p>
@@ -1006,18 +1022,18 @@
             <a:r>
               <a:rPr lang="en-US" dirty="0"/>
               <a:t>notes:
-(2 min) Apply the three-question bar to the just-seen output. If it
-passes, it is a deliverable; if not, it is a draft. This turns the
-demo result into the artefact a Bachelor course can build on next summer semester.
-Repeatability is process-level, not byte-identical output — the model
-is stochastic; the method is re-runnable and auditable. And "citable"
-means the URL resolves AND supports the sentence. Sales connection:
-you verify a prospect's claims before you sign — same discipline here.
-Context framing: each question defends a different way context breaks
-— the agent inventing what it doesn't know, pointing at a source that
-isn't there, or leaving the context in someone's head so the result
-can't be re-derived. That is why the three questions are the
-scientific part, not a formality.</a:t>
+⏱ ~2 min · READ ALOUD
+The last step of the walkthrough: judge the output with three
+questions. Checked — did the agent verify its output, or did it
+just generate it? Citable — does every claim carry a URL that
+resolves, and actually supports the sentence? Repeatable — re-run
+the same contract and you get the same method: a result you can
+audit. And here is what all three are really guarding: context.
+Checked guards against invented context. Citable guards against
+untraceable context. Repeatable guards against lost context. If the
+output passes, it's a deliverable. If not — it's a draft. And that
+is the same discipline you'd apply to a prospect's claims before
+you sign anything. Verify before you trust.</a:t>
             </a:r>
             <a:endParaRPr lang="en-US" dirty="0"/>
           </a:p>
@@ -1106,13 +1122,15 @@
             <a:r>
               <a:rPr lang="en-US" dirty="0"/>
               <a:t>notes:
-(1 min) Close the walkthrough: the students take away the METHOD, not
-just the result. The contract + three questions are the transferable
-part; the harness is a tool they can try themselves afterwards.
-Point to resources slide for how to start.
-Item 4 is the thread made explicit for the first time: the
-walkthrough only worked because context entered via the contract and
-was held honest by the loop.</a:t>
+⏱ ~1 min · READ ALOUD
+So — what did you actually just see? Three things. A contract:
+rules, not a prompt. An agent doing a loop: plan, act, check,
+correct. And a verifiable artefact: a ranked shortlist, every claim
+with a source. And one more thing — the thread of the whole hour.
+Context. Supplied by you. Enforced by the contract. Checked by the
+loop. That's the method — and it's reusable for any
+partner-sourcing task. The result is what a demo produces. The
+method is what you take home.</a:t>
             </a:r>
             <a:endParaRPr lang="en-US" dirty="0"/>
           </a:p>
@@ -1201,9 +1219,17 @@
             <a:r>
               <a:rPr lang="en-US" dirty="0"/>
               <a:t>notes:
-(1.5 min) Make the value exchange explicit — why the chair invested in
-this guest lecture. Also honest note: the method is open and reusable;
-students may embed it in internships and theses.</a:t>
+⏱ ~1.5 min · READ ALOUD
+Fair question: what does the chair get out of this? Four things.
+First, a reproducible partner-sourcing method — not a one-off
+search. Second, a ranked, sourced shortlist — usable immediately.
+Third, students who can run agentic workflows — and I mean that
+seriously as a CV skill; that's what companies are hiring for right
+now. And fourth, an evidence base for the Bachelor course Sales
+Strategy and Execution next summer. One honest note on the side:
+everything here is open and reusable — you can take this method
+into internships and theses. The lecture is not the output. The
+shortlist is.</a:t>
             </a:r>
             <a:endParaRPr lang="en-US" dirty="0"/>
           </a:p>
@@ -1292,14 +1318,18 @@
             <a:r>
               <a:rPr lang="en-US" dirty="0"/>
               <a:t>notes:
-(1.25 min) Practical slide — what students can use NOW. Lead with the
-JLU HRZ API-Service: free LLM endpoints for all JLU members (Qwen
-256K–1M ctx + commercial); access via ki@uni-giessen.de; OpenCode via
-LiteLLM (baseURL api.hrz.uni-giessen.de) or Claude Code via
-ANTHROPIC_BASE_URL. Google: 12 months free AI Plus, verify via
-SheerID, redeem by Dec 31 2026. OpenRouter: one key, many models,
-pay-as-you-go. Ollama: local + free + private. Harnesses: OpenCode and
-pi are what the walkthrough just used.</a:t>
+⏱ ~1.25 min · READ ALOUD
+So what can you use, as a student, starting tomorrow? Best option
+first: the JLU HRZ API-Service. Free LLMs for every university
+member — locally hosted Qwen models with up to a million tokens of
+context, plus the commercial models on top. You get access by
+emailing ki@uni-giessen.de, and it works with OpenCode out of the
+box. Google gives students a year of Google AI Plus for free —
+verify with your university email by the end of December. OpenRouter
+is one key for many models, free tiers included. Ollama runs
+locally — free and private. And the harnesses, OpenCode and pi,
+are what you've seen today. If you take one thing from this slide:
+start with HRZ.</a:t>
             </a:r>
             <a:endParaRPr lang="en-US" dirty="0"/>
           </a:p>
@@ -1388,14 +1418,15 @@
             <a:r>
               <a:rPr lang="en-US" dirty="0"/>
               <a:t>notes:
-(1 min) Recap the four take-aways. Close the loop: the artefact —
-the ranked shortlist — is the evidence base for the Bachelor course
-"Sales Strategy and Execution" next summer semester; the chair decides
-what and how much to use. That is the "output as input" promise from
-the title slide.
-Take-away 5 is the one-liner to leave them with: a small model with
-your context beats a big model with none. That reframe is what makes
-this lecture's message portable beyond today's demo.</a:t>
+⏱ ~1 min · READ ALOUD
+Let me leave you with five lines. Agentic is a working environment,
+not a chatbot. A harness is a model plus tools plus rules — that is
+what makes AI work accountable. Contract first: define 'done'
+before you start. Verify, cite, repeat — the three questions. And
+the line I want you to take home: context beats compute. A small
+model with your context beats a big model with none. Next summer,
+this shortlist becomes the Bachelor course's input — and the chair
+decides what it feeds.</a:t>
             </a:r>
             <a:endParaRPr lang="en-US" dirty="0"/>
           </a:p>
@@ -1484,15 +1515,13 @@
             <a:r>
               <a:rPr lang="en-US" dirty="0"/>
               <a:t>notes:
-(30 s) Do not read aloud; everything here is public and re-usable.
-Lead with HRZ API-Service — it is the free, university-provided LLM
-access for students (request a key via ki@uni-giessen.de; OpenCode
-works with a LiteLLM provider pointing at api.hrz.uni-giessen.de).
-The Google link repeats the providers slide's key offer so it
-survives on its own (e.g. when the slide is shared). The
-marketing-research corpus is the evidence base for the "why now"
-slides; skeleton-research is what a student can fork to run their own
-curated corpus.</a:t>
+⏱ ~30 s · OPTIONAL read — the list stays up on screen either way.
+"Everything on this slide is public and reusable — the links are in
+the deck. Two are worth starting with: the HRZ API-Service, and the
+research corpus itself, which is what today's evidence came from.
+Fork it — it's a skeleton you can grow into your own corpus."
+[If you only say one sentence:] "All links are in the deck — the
+corpus and the one-pager are where I'd start."</a:t>
             </a:r>
             <a:endParaRPr lang="en-US" dirty="0"/>
           </a:p>
@@ -1581,14 +1610,19 @@
             <a:r>
               <a:rPr lang="en-US" dirty="0"/>
               <a:t>notes:
-(45 s) Bridge from the preceding part first: you just heard about
-modern marketing &amp; sales in a digital world — agentic AI is the tooling
-that operationalises exactly that. Then set the concrete goal: by the
-end you can RECOGNISE and judge an agentic workflow — and read the
-contract that drives it.
-The artefact shown in the walkthrough (a ranked lead list with sources)
-becomes evidence the Bachelor course "Sales Strategy and Execution"
-may build on next summer semester.</a:t>
+⏱ ~45 s · READ ALOUD
+[If preceding talker, bridge first:] You just heard about modern
+marketing and sales in a digital world — agentic AI is the tooling
+that puts exactly that into practice.
+Here's the job we're solving. This chair partners with companies —
+for funding, for data, for teaching cases. Finding and qualifying
+those partners is manual work: slow, and it doesn't scale. Agentic
+AI can research companies, score them, and rank them. And let me be
+straight with you: nobody needs another lecture about chatbots.
+What you need is to recognise — and judge — an agentic workflow,
+and to read the contract that drives it. The demo we watch produces
+a ranked list of partners, every claim with a source. That list is
+the dataset our Bachelor students build on next year.</a:t>
             </a:r>
             <a:endParaRPr lang="en-US" dirty="0"/>
           </a:p>
@@ -1677,21 +1711,28 @@
             <a:r>
               <a:rPr lang="en-US" dirty="0"/>
               <a:t>notes:
-(10 min) Q&amp;A + apply the three questions to the walkthrough result.
-Likely questions: model choice (the demo runs on **big pickle**; the
-harness is model-agnostic — pi switches model with Ctrl+L), costs (cheap
-models + tight contracts), data
-privacy (local models), what "qualified" means (the contract), and how
-to try it themselves (resources slide).
-If asked about non-determinism: repeatability is process-level —
-same contract → same method → auditable, re-runnable result; output
-is never guaranteed byte-identical with a stochastic model.
-If asked "isn't this just a fancy search engine?": search returns
-matches; this returns judgements — because the contract carries the
-chair's context and every judgement is source-traceable. Context is
-the difference, and it is yours, not the model's.
-Hard stop at 16:00: the course's Übung starts in the same room right
-after — never overrun Q&amp;A; the ten minutes belong to the students.</a:t>
+⏱ 10 min Q&amp;A — closing words first, then moderation.
+[Closing, ~15 s · READ ALOUD:] "Thank you for listening — and for
+the questions you've banked. Let's hear them, one at a time."
+[Each answer — keep it short, one idea, then ask the next person.]
+Prepared answers you're likely to reach for:
+- Model choice — the demo runs on **big pickle**; the harness is
+  model-agnostic — pi switches model with Ctrl+L. Cost is why we
+  pick cheap models with tight contracts, not size.
+- "Is this just a fancy search engine?" — search returns matches;
+  this returns judgements, because the contract carries the chair's
+  context and every judgement is source-traceable. Context is the
+difference — and it's yours, not the model's.
+- "Is the output reproducible?" — same contract, same method:
+auditable, re-runnable; never promised byte-identical, models are
+stochastic.
+- Data privacy — local models (Ollama, HRZ Qwen) if it matters;
+  today's demo is public data only.
+- "What does qualified mean?" — defined in the contract: fit
+  signal, innovation agenda, university links, each with evidence.
+- Trying it themselves — resources slide; start with HRZ API.
+[Hard stop at 16:00 — the course's Übung starts in this room right
+after; the ten minutes belong to the students, never overrun.]</a:t>
             </a:r>
             <a:endParaRPr lang="en-US" dirty="0"/>
           </a:p>
@@ -1780,11 +1821,15 @@
             <a:r>
               <a:rPr lang="en-US" dirty="0"/>
               <a:t>notes:
-(30 s) Read the rows top to bottom; each becomes a section of the
-lecture. Row 4 notes there is no hands-on today — the walkthrough
-models the method; trying it yourself is the exercise afterwards.
-Row 5 is the thread of the whole talk: intelligence is distributed —
-generation (model), execution (harness), context (you).</a:t>
+⏱ ~30 s · READ ALOUD
+Here's the promise of the next forty-five minutes, in four rows.
+You'll be able to explain what agentic actually means — and why it
+is not a clever chatbot. You'll be able to read how a harness gives
+an AI tools, rules, and a task. You'll be able to judge an agentic
+output — checked? citable? repeatable? And you'll be able to reuse
+the loop you see today: contract, run, verify. One headline before
+we start: model is the brain, harness is the hands, workflow is the
+muscles — and context is the memory. That part is yours.</a:t>
             </a:r>
             <a:endParaRPr lang="en-US" dirty="0"/>
           </a:p>
@@ -1873,11 +1918,12 @@
             <a:r>
               <a:rPr lang="en-US" dirty="0"/>
               <a:t>notes:
-(15 s) Show the arc; the walkthrough (block 3) is where the method
-becomes visible. Q&amp;A is a fixed 10-minute block at the end — bank
-questions during the talk ("hold that for Q&amp;A") to protect the timing.
-The per-slide notes sum to ~32 min; the gap to 35 is deliberate
-buffer for transitions and demo hiccups.</a:t>
+⏱ ~15 s · READ ALOUD
+That's the map for the next thirty-five minutes: foundations first,
+then the method, then the live walkthrough — that is the heart —
+and a short reflection at the end. Ten minutes are reserved for your
+questions. So if one comes to you mid-talk: write it down, we'll
+get to it.</a:t>
             </a:r>
             <a:endParaRPr lang="en-US" dirty="0"/>
           </a:p>
@@ -1966,12 +2012,17 @@
             <a:r>
               <a:rPr lang="en-US" dirty="0"/>
               <a:t>notes:
-(2.5 min) Left: chat — question in, answer out, no tools, no files.
-Right: agent — a goal, a plan, tools, verification, inside a harness
-that grants access. The amber loop is where the work happens.
-The students' common misconception: "agentic = a smarter ChatGPT".
-Set it straight here: it is a difference in kind — the model can
-touch the world (browser, files, APIs) and check its own work.</a:t>
+⏱ ~2.5 min · READ ALOUD
+Let's clear up the most common confusion first. On the left — that's
+chat. Question in, answer out. No tools, no files, no actions: just
+a conversation. On the right — that's an agent: a goal, a plan,
+tools, and verification, running inside a harness that grants it
+access to the world — a browser, files, APIs. The amber loop in the
+middle is where the actual work happens. And here is the key point:
+agentic is not a smarter ChatGPT. It's a difference in kind, not in
+size. The model can touch the world, and it can check its own work.
+Keep this image in your head — it's the whole lecture in one
+picture.</a:t>
             </a:r>
             <a:endParaRPr lang="en-US" dirty="0"/>
           </a:p>
@@ -2060,15 +2111,19 @@
             <a:r>
               <a:rPr lang="en-US" dirty="0"/>
               <a:t>notes:
-(2.5 min) Keep it simple. The model is the part students already know.
-The harness is the missing piece this lecture adds: an executable
-environment (terminal, browser, files) + permissions + memory.
-The loop is what makes it "agentic": it iterates, checks, corrects.
-The fourth ingredient — context — is invisible on this diagram
-because it is yours: the criteria and judgement the loop cannot
-generate for itself. Name it here; slide 8 makes it concrete.
-Why pi as my default today: smaller memory footprint — the honest
-reason, not because the other harnesses are worse.</a:t>
+⏱ ~2.5 min · READ ALOUD
+Three parts. The model — you know this one, it's the brain. The
+harness — that's the piece this lecture adds: an executable
+environment, permissions, memory — the hands and the workspace.
+And the loop — that's what makes it agentic: it plans, it acts, it
+checks, it corrects itself. Two honest asides. First: there's a
+fourth ingredient that is deliberately not on this diagram —
+context, the criteria and judgement the loop cannot invent for
+itself. That's yours, and it comes back in two slides. Second, full
+disclosure: pi, the harness you'll see in the demo, is my own
+project. I use it mainly because it has a small memory footprint.
+OpenCode and Claude Code are solid alternatives. Same model,
+different results — the harness decides.</a:t>
             </a:r>
             <a:endParaRPr lang="en-US" dirty="0"/>
           </a:p>
@@ -2157,16 +2212,17 @@
             <a:r>
               <a:rPr lang="en-US" dirty="0"/>
               <a:t>notes:
-(1.5 min) Ground the hype in the chair's own open corpus
-(marketing-research, public on GitHub). 2026 alone produced 7,771 of
-the 13,096 papers. Agentic exists (91), lead-gen exists (27) — the
-intersection is literally ZERO; say that out loud. Context-aware
-marketing is a live thread (22 papers) but it stays on attribution
-and personalization — never on the agent's working context. So the
-triple intersection is empty: that is the opening, and it is this
-chair's to fill. Honesty note: counts come from keyword search over
-title/abstract in our own corpus — a heuristic, not a citation index
-— but it is conservative; the gap is real and wide.</a:t>
+⏱ ~1.5 min · READ ALOUD
+Why now? Let me show you the evidence — from this chair's own open
+research corpus, public on GitHub. Thirteen thousand and ninety-six
+marketing papers. Seven thousand seven hundred and seventy-one of
+them published in 2026 alone. Ninety-one papers mention agentic AI.
+Twenty-seven papers are about lead generation. And the intersection
+— papers that do both? Zero. Literally zero. Twenty-two papers are
+context-aware — but they all stay in attribution and
+personalisation; none of them touch agentic work. So the triple
+intersection is empty. Nobody is doing this yet — and that empty
+cell is this chair's to fill.</a:t>
             </a:r>
             <a:endParaRPr lang="en-US" dirty="0"/>
           </a:p>
@@ -2255,13 +2311,18 @@
             <a:r>
               <a:rPr lang="en-US" dirty="0"/>
               <a:t>notes:
-(2 min) The central mental model of the lecture: prompts are how you
-ask a chat; contracts are how you run an agent. A contract lives in
-the repo, is versioned, and says what done means. This is what turns
-an AI "idea generator" into a reproducible research pipeline.
-Context beat: the contract is a container for context — the chair's
-criteria, sources, judgement, partnership history. Without it the
-agent is a brilliant generalist with no idea what "good" means here.</a:t>
+⏱ ~2 min · READ ALOUD
+This is the central mental model of the whole lecture — it's the
+slide I hope you remember. A prompt? That's how you ask a chat: a
+question, in one go, and that's it. A contract? That's how you run
+an agent. It lives in the repository, it's versioned, and it says
+what 'done' means. And then the third piece, please take it
+seriously: context. The contract is a container for context — the
+chair's criteria, the sources we trust, our judgement, the history
+of partnerships. Without that container, the agent is a brilliant
+generalist with no idea what 'good' means here. A prompt turns an
+idea-generator into a conversation. A contract turns it into a
+reproducible research pipeline.</a:t>
             </a:r>
             <a:endParaRPr lang="en-US" dirty="0"/>
           </a:p>
@@ -2350,18 +2411,20 @@
             <a:r>
               <a:rPr lang="en-US" dirty="0"/>
               <a:t>notes:
-(3 min) Walk the diagram left to right: DEFINE (human, blue) → SOURCE
-→ QUALIFY → RECORD → VERIFY → OUTPUT (human, green). The agent runs
-the middle four; the human sets criteria and judges the result. The
-amber feedback line: what you learn from a run updates the contract —
-you edit the criteria before the next run; the agent stays inside the
-loop, the human stays in charge. This exact pipeline is what the
-walkthrough demonstrates live in the next block. The next slide makes
-DEFINE concrete: the sector choice — still human work.
-Context mapping: DEFINE injects context (criteria, sector, guard
-rails); EVALUATE judges with context (the three questions). The amber
-line is context flowing back — what a run teaches updates the
-contract for the next run.</a:t>
+⏱ ~3 min · READ ALOUD
+Now let's make it concrete — a lead-generation loop as an agentic
+workflow. Read it left to right. [point to each box as you say it]
+DEFINE — that's you; that's the blue box: what does a good partner
+look like for this chair? SOURCE — where do we hunt? QUALIFY —
+does this company actually fit? RECORD — capture every claim with
+its source. VERIFY — check those sources really say what we think
+they say. And OUTPUT — a ranked list, judged by a human. The agent
+runs the middle four steps. You own the first and the last — and
+you already know why from the slide before: those two boxes are
+where the context lives. Notice the amber line along the bottom —
+that's what you learn on a run, feeding back to tighten the
+contract for the next run. The agent stays inside the loop. The
+human stays in charge.</a:t>
             </a:r>
             <a:endParaRPr lang="en-US" dirty="0"/>
           </a:p>

</xml_diff>

<commit_message>
lecture: fix speaker-notes leaks — move [Not read]/[jot] directives inside notes comments (14 blocks were rendering onto slides); all 20 slides overflow-free, verified headless
</commit_message>
<xml_diff>
--- a/lecture/agentic-ai-for-lead-generation.pptx
+++ b/lecture/agentic-ai-for-lead-generation.pptx
@@ -628,7 +628,9 @@
 engineering wins on every axis. So that's the sector you're about
 to see in the demo. And notice what just happened: the AI did not
 choose the sector. We did. Choosing target segments is a core
-sales-strategy decision — one we can teach in the Bachelor course.</a:t>
+sales-strategy decision — one we can teach in the Bachelor course.
+[Not read:] This is the DEFINE box made concrete; guards the claim
+the walkthrough is human-steered, not agent-chosen.</a:t>
             </a:r>
             <a:endParaRPr lang="en-US" dirty="0"/>
           </a:p>
@@ -825,7 +827,9 @@
 go on — because it really matters: every source this contract
 lists is self-reported by the companies themselves. A URL proves a
 claim exists; it does not prove the claim is true. So the standing
-question for everything we do today is: whose evidence is this?</a:t>
+question for everything we do today is: whose evidence is this?
+[Not read:] The live file is lecture/demo/AGENTS.md; full kickoff
+prompt + narration: lecture/demo/demo-script.md.</a:t>
             </a:r>
             <a:endParaRPr lang="en-US" dirty="0"/>
           </a:p>
@@ -933,7 +937,15 @@
 [it re-checks citations] "Now it's re-checking its own citations —
 do those URLs actually resolve? That's step five: verify."
 [final table] "And there's the shortlist — ranked, cited, done.
-Let's judge it with the three questions."</a:t>
+Let's judge it with the three questions."
+[Not read:] Steps: (1) open browser via MCP, search prospects;
+(2) read real pages, extract fit signals; (3) score vs contract;
+(4) write markdown table with URLs; (5) re-check citations;
+(6) ranked list. Speed beats completeness — cut company two if
+running long. Demo runs on real public data via cloud API — never
+paste private/customer data. Fallback: no network → play
+fallback-demo.mp4 and narrate the same beats over it (see
+demo/demo-script.md).</a:t>
             </a:r>
             <a:endParaRPr lang="en-US" dirty="0"/>
           </a:p>
@@ -1033,7 +1045,10 @@
 untraceable context. Repeatable guards against lost context. If the
 output passes, it's a deliverable. If not — it's a draft. And that
 is the same discipline you'd apply to a prospect's claims before
-you sign anything. Verify before you trust.</a:t>
+you sign anything. Verify before you trust.
+[Not read:] Repeatability is process-level, not byte-identical
+output — models are stochastic, the method is re-runnable. Sales
+connection: you verify a prospect's claims before signing.</a:t>
             </a:r>
             <a:endParaRPr lang="en-US" dirty="0"/>
           </a:p>
@@ -1130,7 +1145,9 @@
 Context. Supplied by you. Enforced by the contract. Checked by the
 loop. That's the method — and it's reusable for any
 partner-sourcing task. The result is what a demo produces. The
-method is what you take home.</a:t>
+method is what you take home.
+[Not read:] Point to resources slide for how to start trying it
+yourself.</a:t>
             </a:r>
             <a:endParaRPr lang="en-US" dirty="0"/>
           </a:p>
@@ -1329,7 +1346,11 @@
 is one key for many models, free tiers included. Ollama runs
 locally — free and private. And the harnesses, OpenCode and pi,
 are what you've seen today. If you take one thing from this slide:
-start with HRZ.</a:t>
+start with HRZ.
+[Not read — for questions:] Google deal redeem by Dec 31 2026,
+SheerID verification; OpenCode via LiteLLM provider block
+(baseURL api.hrz.uni-giessen.de) or Claude Code via
+ANTHROPIC_BASE_URL.</a:t>
             </a:r>
             <a:endParaRPr lang="en-US" dirty="0"/>
           </a:p>
@@ -1426,7 +1447,9 @@
 the line I want you to take home: context beats compute. A small
 model with your context beats a big model with none. Next summer,
 this shortlist becomes the Bachelor course's input — and the chair
-decides what it feeds.</a:t>
+decides what it feeds.
+[Not read:] Take-away 5 is the portable one-liner; it reframes the
+lecture beyond today's demo.</a:t>
             </a:r>
             <a:endParaRPr lang="en-US" dirty="0"/>
           </a:p>
@@ -1521,7 +1544,12 @@
 research corpus itself, which is what today's evidence came from.
 Fork it — it's a skeleton you can grow into your own corpus."
 [If you only say one sentence:] "All links are in the deck — the
-corpus and the one-pager are where I'd start."</a:t>
+corpus and the one-pager are where I'd start."
+[Not read:] Lead with HRZ API-Service (free, university-provided).
+Google link repeats the providers slide so it survives sharing.
+marketing-research = evidence base of the "why now" slides;
+skeleton-research = forkable starter for a student's own curated
+corpus; hrz-access-one-pager.md = student quick start.</a:t>
             </a:r>
             <a:endParaRPr lang="en-US" dirty="0"/>
           </a:p>
@@ -1622,7 +1650,9 @@
 What you need is to recognise — and judge — an agentic workflow,
 and to read the contract that drives it. The demo we watch produces
 a ranked list of partners, every claim with a source. That list is
-the dataset our Bachelor students build on next year.</a:t>
+the dataset our Bachelor students build on next year.
+[jot: the "ranked list" is the handoff artefact — the
+"output as input" promise. Protect it; it returns on slides 16/18.]</a:t>
             </a:r>
             <a:endParaRPr lang="en-US" dirty="0"/>
           </a:p>
@@ -1829,7 +1859,10 @@
 output — checked? citable? repeatable? And you'll be able to reuse
 the loop you see today: contract, run, verify. One headline before
 we start: model is the brain, harness is the hands, workflow is the
-muscles — and context is the memory. That part is yours.</a:t>
+muscles — and context is the memory. That part is yours.
+[Not read — colour:] Row 5 is the thread of the whole talk:
+intelligence is distributed — generation (model), execution
+(harness), context (you).</a:t>
             </a:r>
             <a:endParaRPr lang="en-US" dirty="0"/>
           </a:p>
@@ -1923,7 +1956,10 @@
 then the method, then the live walkthrough — that is the heart —
 and a short reflection at the end. Ten minutes are reserved for your
 questions. So if one comes to you mid-talk: write it down, we'll
-get to it.</a:t>
+get to it.
+[Not read:] The notes sum to ~32 min; the gap to 35 is deliberate
+buffer for transitions and demo hiccups. Q&amp;A is fixed at 10 min —
+bank questions with "hold that for Q&amp;A".</a:t>
             </a:r>
             <a:endParaRPr lang="en-US" dirty="0"/>
           </a:p>
@@ -2123,7 +2159,9 @@
 disclosure: pi, the harness you'll see in the demo, is my own
 project. I use it mainly because it has a small memory footprint.
 OpenCode and Claude Code are solid alternatives. Same model,
-different results — the harness decides.</a:t>
+different results — the harness decides.
+[Not read:] If asked later — pi default is memory footprint, not
+"my software is better"; keep it honest, students test this.</a:t>
             </a:r>
             <a:endParaRPr lang="en-US" dirty="0"/>
           </a:p>
@@ -2222,7 +2260,10 @@
 context-aware — but they all stay in attribution and
 personalisation; none of them touch agentic work. So the triple
 intersection is empty. Nobody is doing this yet — and that empty
-cell is this chair's to fill.</a:t>
+cell is this chair's to fill.
+[Not read — honesty note if probed:] Counts come from keyword search
+over title/abstract of our own corpus — a heuristic, not a citation
+index — but conservative; the gap is real and wide.</a:t>
             </a:r>
             <a:endParaRPr lang="en-US" dirty="0"/>
           </a:p>
@@ -2424,7 +2465,10 @@
 where the context lives. Notice the amber line along the bottom —
 that's what you learn on a run, feeding back to tighten the
 contract for the next run. The agent stays inside the loop. The
-human stays in charge.</a:t>
+human stays in charge.
+[Not read:] DEFINE injects context (criteria, sector, guard rails);
+EVALUATE judges with context (the three questions). Next slide makes
+DEFINE concrete — the sector choice, still human work.</a:t>
             </a:r>
             <a:endParaRPr lang="en-US" dirty="0"/>
           </a:p>

</xml_diff>

<commit_message>
lecture: deslop speaker notes — strip filler openers, redundant intensifiers and performative hedges; tighten all 20 blocks to crisp spoken prose (word count down ~7%)
</commit_message>
<xml_diff>
--- a/lecture/agentic-ai-for-lead-generation.pptx
+++ b/lecture/agentic-ai-for-lead-generation.pptx
@@ -523,14 +523,13 @@
               <a:rPr lang="en-US" dirty="0"/>
               <a:t>notes:
 ⏱ ~45 s · READ ALOUD
-Good afternoon — and thank you for having me. Here's what this
-session is about: agentic AI — what it is, and how you run it so
-that its work is trustworthy. And everything we do today maps onto
-one real task: helping this chair find and qualify B2B partner
-companies. The shortlist the agent produces is evidence for our
-Bachelor course Sales Strategy and Execution next summer. So
-nothing here is an exercise — it's the start of a deliverable.
-Let's get going.</a:t>
+Good afternoon — thank you for having me. This session is about
+agentic AI: what it is, and how to run it so its work is
+trustworthy. Everything today maps onto one real task — helping
+this chair find and qualify B2B partner companies. The shortlist
+the agent produces is evidence for our Bachelor course Sales
+Strategy and Execution next summer. Nothing here is an exercise.
+It is the start of a deliverable. Let's begin.</a:t>
             </a:r>
             <a:endParaRPr lang="en-US" dirty="0"/>
           </a:p>
@@ -621,14 +620,14 @@
               <a:t>notes:
 ⏱ ~45 s · READ ALOUD
 Before the agent does anything, a human decides where to hunt.
-Look at this table: five criteria, scored one to five, and one hard
-guard. Our first default — grocery retail — fails the guard,
-because lead generation there is a consumer, demand-gen game, not a
-sales-strategy one. Optics came close. But mechanical and plant
-engineering wins on every axis. So that's the sector you're about
-to see in the demo. And notice what just happened: the AI did not
-choose the sector. We did. Choosing target segments is a core
-sales-strategy decision — one we can teach in the Bachelor course.
+Look at the table: five criteria, scored one to five, plus one hard
+guard. Our first default — grocery retail — fails the guard: lead
+generation there is a consumer, demand-gen game, not a
+sales-strategy one. Optics came close. Mechanical and plant
+engineering wins on every axis. That's the sector you'll see in the
+demo. And notice what just happened: the AI did not choose the
+sector. We did. Choosing target segments is a core sales-strategy
+decision — one we can teach in the Bachelor course.
 [Not read:] This is the DEFINE box made concrete; guards the claim
 the walkthrough is human-steered, not agent-chosen.</a:t>
             </a:r>
@@ -720,15 +719,14 @@
               <a:rPr lang="en-US" dirty="0"/>
               <a:t>notes:
 ⏱ ~30 s · READ ALOUD
-So — the live walkthrough. The task: build the partner-candidate
-shortlist, top ten B2B companies. Live today, we'll do two of them
-— the method is what matters, not the count. Each company gets a
-fit signal in one sentence, every claim carries a source URL, and
-the output is ranked. That shortlist is evidence for the Bachelor
-course next year. There's no hands-on today — this is a
-walkthrough. I run it in the harness live, and what you see is what
-the agent does. Watch what happens — and watch what doesn't happen
-on screen. Let's go.</a:t>
+The live walkthrough. Task: build the partner-candidate shortlist
+— top ten B2B companies. Live today, two of them; the method is
+what matters. Each company gets a fit signal in one sentence, every
+claim carries a source URL, the output is ranked. That shortlist is
+evidence for the Bachelor course next year. No hands-on today —
+this is a walkthrough. I run it in the harness live; what you see
+is what the agent does. Watch what happens — and what doesn't.
+Let's go.</a:t>
             </a:r>
             <a:endParaRPr lang="en-US" dirty="0"/>
           </a:p>
@@ -818,16 +816,15 @@
               <a:rPr lang="en-US" dirty="0"/>
               <a:t>notes:
 ⏱ ~2 min · READ ALOUD
-Step one: the contract. This is the file the agent reads every time
-it starts — and it's in this repository, you can open it yourself.
-Look at what a contract actually contains: a goal, criteria,
-sources, an output format, and rules. Now, the natural instinct is
-to think you prompt an AI by typing a question. You don't. You
-start by writing rules. And one critical-literacy point before we
-go on — because it really matters: every source this contract
-lists is self-reported by the companies themselves. A URL proves a
-claim exists; it does not prove the claim is true. So the standing
-question for everything we do today is: whose evidence is this?
+Step one: the contract. The file the agent reads every time it
+starts — and it's in this repository, open to you. Look at what a
+contract contains: a goal, criteria, sources, an output format,
+rules. The natural instinct is that you prompt an AI by typing a
+question. You don't. You start by writing rules. One
+critical-literacy point before we go on: every source this contract
+lists is self-reported by the companies. A URL proves a claim
+exists; it does not prove the claim is true. So the standing
+question today is: whose evidence is this?
 [Not read:] The live file is lecture/demo/AGENTS.md; full kickoff
 prompt + narration: lecture/demo/demo-script.md.</a:t>
             </a:r>
@@ -922,22 +919,21 @@
 [agent starts] "I'm introducing the agent the way I'd introduce a
 new colleague: here's the contract, here's the task — show me your
 plan first."
-[it plans] "Watch the plan — it maps one to one onto those six boxes
+[it plans] "Watch the plan — it maps one-to-one onto the six boxes
 from the pipeline slide."
-[it opens the browser] "There it is — it can touch the world, that's
+[it opens the browser] "There it is — it can touch the world; that's
 what agentic means. It's reading the companies' own pages. Right
 now it is absorbing our context — the criteria it could not invent
 for itself."
-[it scores] "Now it scores each company against the contract — fit
-signal, one sentence, with the source right next to it."
-[on a mistake — pause, then:] "Hold on. Did you see that? It
-over-claimed. Stop. Which URL actually says that?" [let it
-correct itself] "That pause-and-correct — that is the loop in
-action."
-[it re-checks citations] "Now it's re-checking its own citations —
-do those URLs actually resolve? That's step five: verify."
-[final table] "And there's the shortlist — ranked, cited, done.
-Let's judge it with the three questions."
+[it scores] "It scores each company against the contract — fit
+signal, one sentence, source alongside."
+[on a mistake — pause, then:] "Hold on. It over-claimed. Stop.
+Which URL says that?" [let it correct itself] "That
+pause-and-correct is the loop in action."
+[it re-checks citations] "It's re-checking its own citations — do
+those URLs resolve? That's step five: verify."
+[final table] "There's the shortlist — ranked, cited. Let's judge it
+with the three questions."
 [Not read:] Steps: (1) open browser via MCP, search prospects;
 (2) read real pages, extract fit signals; (3) score vs contract;
 (4) write markdown table with URLs; (5) re-check citations;
@@ -1036,16 +1032,15 @@
               <a:t>notes:
 ⏱ ~2 min · READ ALOUD
 The last step of the walkthrough: judge the output with three
-questions. Checked — did the agent verify its output, or did it
-just generate it? Citable — does every claim carry a URL that
-resolves, and actually supports the sentence? Repeatable — re-run
-the same contract and you get the same method: a result you can
-audit. And here is what all three are really guarding: context.
+questions. Checked — did the agent verify its output, or just
+generate it? Citable — does every claim carry a URL that resolves
+and supports the sentence? Repeatable — re-run the same contract,
+same method: a result you can audit. All three guard context.
 Checked guards against invented context. Citable guards against
 untraceable context. Repeatable guards against lost context. If the
-output passes, it's a deliverable. If not — it's a draft. And that
-is the same discipline you'd apply to a prospect's claims before
-you sign anything. Verify before you trust.
+output passes, it's a deliverable. If not, it's a draft. Same
+discipline as verifying a prospect's claims before you sign.
+Verify before you trust.
 [Not read:] Repeatability is process-level, not byte-identical
 output — models are stochastic, the method is re-runnable. Sales
 connection: you verify a prospect's claims before signing.</a:t>
@@ -1138,14 +1133,13 @@
               <a:rPr lang="en-US" dirty="0"/>
               <a:t>notes:
 ⏱ ~1 min · READ ALOUD
-So — what did you actually just see? Three things. A contract:
-rules, not a prompt. An agent doing a loop: plan, act, check,
-correct. And a verifiable artefact: a ranked shortlist, every claim
-with a source. And one more thing — the thread of the whole hour.
-Context. Supplied by you. Enforced by the contract. Checked by the
-loop. That's the method — and it's reusable for any
-partner-sourcing task. The result is what a demo produces. The
-method is what you take home.
+What did you just see? Three things. A contract — rules, not a
+prompt. An agent doing a loop — plan, act, check, correct. A
+verifiable artefact — a ranked shortlist, every claim with a
+source. And one more thing, the thread of the hour: context.
+Supplied by you. Enforced by the contract. Checked by the loop.
+That's the method — reusable for any partner-sourcing task. The
+result is what a demo produces. The method is what you take home.
 [Not read:] Point to resources slide for how to start trying it
 yourself.</a:t>
             </a:r>
@@ -1237,16 +1231,14 @@
               <a:rPr lang="en-US" dirty="0"/>
               <a:t>notes:
 ⏱ ~1.5 min · READ ALOUD
-Fair question: what does the chair get out of this? Four things.
-First, a reproducible partner-sourcing method — not a one-off
-search. Second, a ranked, sourced shortlist — usable immediately.
-Third, students who can run agentic workflows — and I mean that
-seriously as a CV skill; that's what companies are hiring for right
-now. And fourth, an evidence base for the Bachelor course Sales
-Strategy and Execution next summer. One honest note on the side:
-everything here is open and reusable — you can take this method
-into internships and theses. The lecture is not the output. The
-shortlist is.</a:t>
+What does the chair get out of this? Four things. A reproducible
+partner-sourcing method — not a one-off search. A ranked, sourced
+shortlist — usable immediately. Students who can run agentic
+workflows — a real CV skill; that's what companies hire for now.
+And an evidence base for the Bachelor course Sales Strategy and
+Execution next summer. One note: everything here is open and
+reusable — you can take this method into internships and theses.
+The lecture is not the output. The shortlist is.</a:t>
             </a:r>
             <a:endParaRPr lang="en-US" dirty="0"/>
           </a:p>
@@ -1336,17 +1328,16 @@
               <a:rPr lang="en-US" dirty="0"/>
               <a:t>notes:
 ⏱ ~1.25 min · READ ALOUD
-So what can you use, as a student, starting tomorrow? Best option
+What can you use as a student, starting tomorrow? Best option
 first: the JLU HRZ API-Service. Free LLMs for every university
 member — locally hosted Qwen models with up to a million tokens of
-context, plus the commercial models on top. You get access by
-emailing ki@uni-giessen.de, and it works with OpenCode out of the
-box. Google gives students a year of Google AI Plus for free —
-verify with your university email by the end of December. OpenRouter
-is one key for many models, free tiers included. Ollama runs
-locally — free and private. And the harnesses, OpenCode and pi,
-are what you've seen today. If you take one thing from this slide:
-start with HRZ.
+context, plus commercial models. Access by emailing
+ki@uni-giessen.de; works with OpenCode out of the box. Google gives
+students a year of Google AI Plus free — verify with your
+university email by the end of December. OpenRouter: one key, many
+models, free tiers included. Ollama runs locally — free and
+private. And the harnesses, OpenCode and pi, are what you've seen
+today. If you take one thing from this slide: start with HRZ.
 [Not read — for questions:] Google deal redeem by Dec 31 2026,
 SheerID verification; OpenCode via LiteLLM provider block
 (baseURL api.hrz.uni-giessen.de) or Claude Code via
@@ -1440,14 +1431,14 @@
               <a:rPr lang="en-US" dirty="0"/>
               <a:t>notes:
 ⏱ ~1 min · READ ALOUD
-Let me leave you with five lines. Agentic is a working environment,
-not a chatbot. A harness is a model plus tools plus rules — that is
-what makes AI work accountable. Contract first: define 'done'
-before you start. Verify, cite, repeat — the three questions. And
-the line I want you to take home: context beats compute. A small
-model with your context beats a big model with none. Next summer,
-this shortlist becomes the Bachelor course's input — and the chair
-decides what it feeds.
+Five lines to take home. Agentic is a working environment, not a
+chatbot. A harness is a model plus tools plus rules — that's what
+makes AI work accountable. Contract first: define 'done' before
+you start. Verify, cite, repeat — the three questions. And the one
+to remember: context beats compute. A small model with your
+context beats a big model with none. Next summer, this shortlist
+becomes the Bachelor course's input — the chair decides what it
+feeds.
 [Not read:] Take-away 5 is the portable one-liner; it reframes the
 lecture beyond today's demo.</a:t>
             </a:r>
@@ -1541,8 +1532,8 @@
 ⏱ ~30 s · OPTIONAL read — the list stays up on screen either way.
 "Everything on this slide is public and reusable — the links are in
 the deck. Two are worth starting with: the HRZ API-Service, and the
-research corpus itself, which is what today's evidence came from.
-Fork it — it's a skeleton you can grow into your own corpus."
+research corpus that today's evidence came from. Fork it — it's a
+skeleton you can grow into your own corpus."
 [If you only say one sentence:] "All links are in the deck — the
 corpus and the one-pager are where I'd start."
 [Not read:] Lead with HRZ API-Service (free, university-provided).
@@ -1642,15 +1633,15 @@
 [If preceding talker, bridge first:] You just heard about modern
 marketing and sales in a digital world — agentic AI is the tooling
 that puts exactly that into practice.
-Here's the job we're solving. This chair partners with companies —
-for funding, for data, for teaching cases. Finding and qualifying
-those partners is manual work: slow, and it doesn't scale. Agentic
-AI can research companies, score them, and rank them. And let me be
-straight with you: nobody needs another lecture about chatbots.
-What you need is to recognise — and judge — an agentic workflow,
-and to read the contract that drives it. The demo we watch produces
-a ranked list of partners, every claim with a source. That list is
-the dataset our Bachelor students build on next year.
+The chair partners with companies — for funding, for data, for
+teaching cases. Finding and qualifying those partners is manual
+work: slow, and it doesn't scale. Agentic AI can research
+companies, score them, and rank them. And be clear: nobody needs
+another lecture about chatbots. What you need is to recognise —
+and judge — an agentic workflow, and to read the contract that
+drives it. The demo produces a ranked list of partners, every claim
+with a source. That list is the dataset the Bachelor course builds
+on next year.
 [jot: the "ranked list" is the handoff artefact — the
 "output as input" promise. Protect it; it returns on slides 16/18.]</a:t>
             </a:r>
@@ -1754,8 +1745,8 @@
   context and every judgement is source-traceable. Context is the
 difference — and it's yours, not the model's.
 - "Is the output reproducible?" — same contract, same method:
-auditable, re-runnable; never promised byte-identical, models are
-stochastic.
+  auditable, re-runnable; never promised byte-identical, models are
+  stochastic.
 - Data privacy — local models (Ollama, HRZ Qwen) if it matters;
   today's demo is public data only.
 - "What does qualified mean?" — defined in the contract: fit
@@ -1853,12 +1844,12 @@
               <a:t>notes:
 ⏱ ~30 s · READ ALOUD
 Here's the promise of the next forty-five minutes, in four rows.
-You'll be able to explain what agentic actually means — and why it
-is not a clever chatbot. You'll be able to read how a harness gives
-an AI tools, rules, and a task. You'll be able to judge an agentic
-output — checked? citable? repeatable? And you'll be able to reuse
-the loop you see today: contract, run, verify. One headline before
-we start: model is the brain, harness is the hands, workflow is the
+You'll be able to explain what agentic means — and why it is not
+a clever chatbot. You'll be able to read how a harness gives an AI
+tools, rules, and a task. You'll be able to judge an agentic output
+— checked? citable? repeatable? And you'll be able to reuse the
+loop you see today: contract, run, verify. One headline before we
+start: model is the brain, harness is the hands, workflow is the
 muscles — and context is the memory. That part is yours.
 [Not read — colour:] Row 5 is the thread of the whole talk:
 intelligence is distributed — generation (model), execution
@@ -1952,11 +1943,10 @@
               <a:rPr lang="en-US" dirty="0"/>
               <a:t>notes:
 ⏱ ~15 s · READ ALOUD
-That's the map for the next thirty-five minutes: foundations first,
-then the method, then the live walkthrough — that is the heart —
-and a short reflection at the end. Ten minutes are reserved for your
-questions. So if one comes to you mid-talk: write it down, we'll
-get to it.
+The map for the next thirty-five minutes: foundations first, then
+the method, then the live walkthrough — the heart — and a short
+reflection at the end. Ten minutes are reserved for your questions.
+If one comes to you mid-talk, write it down — we'll get to it.
 [Not read:] The notes sum to ~32 min; the gap to 35 is deliberate
 buffer for transitions and demo hiccups. Q&amp;A is fixed at 10 min —
 bank questions with "hold that for Q&amp;A".</a:t>
@@ -2049,16 +2039,15 @@
               <a:rPr lang="en-US" dirty="0"/>
               <a:t>notes:
 ⏱ ~2.5 min · READ ALOUD
-Let's clear up the most common confusion first. On the left — that's
-chat. Question in, answer out. No tools, no files, no actions: just
-a conversation. On the right — that's an agent: a goal, a plan,
-tools, and verification, running inside a harness that grants it
-access to the world — a browser, files, APIs. The amber loop in the
-middle is where the actual work happens. And here is the key point:
-agentic is not a smarter ChatGPT. It's a difference in kind, not in
-size. The model can touch the world, and it can check its own work.
-Keep this image in your head — it's the whole lecture in one
-picture.</a:t>
+Let's clear up the most common confusion first. On the left: chat.
+Question in, answer out. No tools, no files, no actions — a
+conversation. On the right: an agent — a goal, a plan, tools,
+verification, running inside a harness that grants it access to the
+world: a browser, files, APIs. The amber loop in the middle is
+where the work happens. The key point: agentic is not a smarter
+ChatGPT. It is a difference in kind, not in size. The model can
+touch the world, and it can check its own work. Keep this image —
+it's the whole lecture in one picture.</a:t>
             </a:r>
             <a:endParaRPr lang="en-US" dirty="0"/>
           </a:p>
@@ -2148,18 +2137,17 @@
               <a:rPr lang="en-US" dirty="0"/>
               <a:t>notes:
 ⏱ ~2.5 min · READ ALOUD
-Three parts. The model — you know this one, it's the brain. The
-harness — that's the piece this lecture adds: an executable
-environment, permissions, memory — the hands and the workspace.
-And the loop — that's what makes it agentic: it plans, it acts, it
-checks, it corrects itself. Two honest asides. First: there's a
-fourth ingredient that is deliberately not on this diagram —
-context, the criteria and judgement the loop cannot invent for
-itself. That's yours, and it comes back in two slides. Second, full
-disclosure: pi, the harness you'll see in the demo, is my own
-project. I use it mainly because it has a small memory footprint.
-OpenCode and Claude Code are solid alternatives. Same model,
-different results — the harness decides.
+Three parts. The model — the brain. The harness — the piece this
+lecture adds: an executable environment, permissions, memory — the
+hands and the workspace. And the loop — what makes it agentic: it
+plans, acts, checks, corrects itself. Two asides. First: a fourth
+ingredient is deliberately not on this diagram — context, the
+criteria and judgement the loop cannot invent for itself. That's
+yours, and it comes back in two slides. Second, full disclosure:
+pi, the harness you see in the demo, is my own project. I use it
+mainly for its small memory footprint. OpenCode and Claude Code are
+solid alternatives. Same model, different results — the harness
+decides.
 [Not read:] If asked later — pi default is memory footprint, not
 "my software is better"; keep it honest, students test this.</a:t>
             </a:r>
@@ -2251,16 +2239,15 @@
               <a:rPr lang="en-US" dirty="0"/>
               <a:t>notes:
 ⏱ ~1.5 min · READ ALOUD
-Why now? Let me show you the evidence — from this chair's own open
-research corpus, public on GitHub. Thirteen thousand and ninety-six
-marketing papers. Seven thousand seven hundred and seventy-one of
-them published in 2026 alone. Ninety-one papers mention agentic AI.
-Twenty-seven papers are about lead generation. And the intersection
-— papers that do both? Zero. Literally zero. Twenty-two papers are
-context-aware — but they all stay in attribution and
-personalisation; none of them touch agentic work. So the triple
-intersection is empty. Nobody is doing this yet — and that empty
-cell is this chair's to fill.
+Why now? The evidence — from this chair's own open research corpus,
+public on GitHub. Thirteen thousand and ninety-six marketing
+papers. Seven thousand seven hundred and seventy-one published in
+2026 alone. Ninety-one papers mention agentic AI. Twenty-seven are
+about lead generation. The intersection — papers that do both?
+Zero. Twenty-two papers are context-aware — all in attribution and
+personalisation; none touch agentic work. The triple intersection
+is empty. Nobody is doing this yet — and that empty cell is this
+chair's to fill.
 [Not read — honesty note if probed:] Counts come from keyword search
 over title/abstract of our own corpus — a heuristic, not a citation
 index — but conservative; the gap is real and wide.</a:t>
@@ -2353,17 +2340,15 @@
               <a:rPr lang="en-US" dirty="0"/>
               <a:t>notes:
 ⏱ ~2 min · READ ALOUD
-This is the central mental model of the whole lecture — it's the
-slide I hope you remember. A prompt? That's how you ask a chat: a
-question, in one go, and that's it. A contract? That's how you run
-an agent. It lives in the repository, it's versioned, and it says
-what 'done' means. And then the third piece, please take it
-seriously: context. The contract is a container for context — the
-chair's criteria, the sources we trust, our judgement, the history
-of partnerships. Without that container, the agent is a brilliant
-generalist with no idea what 'good' means here. A prompt turns an
-idea-generator into a conversation. A contract turns it into a
-reproducible research pipeline.</a:t>
+This is the central mental model of the lecture. A prompt is how
+you ask a chat: a question, in one go. A contract is how you run an
+agent: it lives in the repository, it's versioned, it says what
+'done' means. And the third piece: context. The contract is a
+container for context — the chair's criteria, the sources we trust,
+our judgement, the history of partnerships. Without it, the agent
+is a brilliant generalist with no idea what 'good' means here. A
+prompt turns an idea-generator into a conversation. A contract
+turns it into a reproducible research pipeline.</a:t>
             </a:r>
             <a:endParaRPr lang="en-US" dirty="0"/>
           </a:p>
@@ -2453,17 +2438,16 @@
               <a:rPr lang="en-US" dirty="0"/>
               <a:t>notes:
 ⏱ ~3 min · READ ALOUD
-Now let's make it concrete — a lead-generation loop as an agentic
+Let's make it concrete — a lead-generation loop as an agentic
 workflow. Read it left to right. [point to each box as you say it]
-DEFINE — that's you; that's the blue box: what does a good partner
-look like for this chair? SOURCE — where do we hunt? QUALIFY —
-does this company actually fit? RECORD — capture every claim with
-its source. VERIFY — check those sources really say what we think
-they say. And OUTPUT — a ranked list, judged by a human. The agent
-runs the middle four steps. You own the first and the last — and
-you already know why from the slide before: those two boxes are
-where the context lives. Notice the amber line along the bottom —
-that's what you learn on a run, feeding back to tighten the
+DEFINE — you: the blue box. What does a good partner look like for
+this chair? SOURCE — where do we hunt? QUALIFY — does this company
+fit? RECORD — capture every claim with its source. VERIFY — check
+those sources say what we think they say. OUTPUT — a ranked list,
+judged by a human. The agent runs the middle four steps. You own
+the first and the last — and you know why from the slide before:
+those two boxes are where the context lives. The amber line along
+the bottom: what you learn on a run feeds back to tighten the
 contract for the next run. The agent stays inside the loop. The
 human stays in charge.
 [Not read:] DEFINE injects context (criteria, sector, guard rails);

</xml_diff>

<commit_message>
lecture: refresh corpus evidence on 'why now' (14,044 papers / 8,702 in 2026 / agentic 107 — 95 this year / lead-gen 31 / intersection 0 / context-aware 23; corpus regenerated 19 Oct) and remove pi-ownership disclosure (slides 6, 17, 19)
</commit_message>
<xml_diff>
--- a/lecture/agentic-ai-for-lead-generation.pptx
+++ b/lecture/agentic-ai-for-lead-generation.pptx
@@ -2143,13 +2143,12 @@
 plans, acts, checks, corrects itself. Two asides. First: a fourth
 ingredient is deliberately not on this diagram — context, the
 criteria and judgement the loop cannot invent for itself. That's
-yours, and it comes back in two slides. Second, full disclosure:
-pi, the harness you see in the demo, is my own project. I use it
-mainly for its small memory footprint. OpenCode and Claude Code are
-solid alternatives. Same model, different results — the harness
-decides.
-[Not read:] If asked later — pi default is memory footprint, not
-"my software is better"; keep it honest, students test this.</a:t>
+yours, and it comes back in two slides. Second: pi is the harness
+you see in the demo. I use it mainly for its small memory footprint.
+OpenCode and Claude Code are solid alternatives. Same model,
+different results — the harness decides.
+[Not read:] If asked why pi — small memory footprint; OpenCode and
+Claude Code are solid alternatives.</a:t>
             </a:r>
             <a:endParaRPr lang="en-US" dirty="0"/>
           </a:p>
@@ -2240,17 +2239,19 @@
               <a:t>notes:
 ⏱ ~1.5 min · READ ALOUD
 Why now? The evidence — from this chair's own open research corpus,
-public on GitHub. Thirteen thousand and ninety-six marketing
-papers. Seven thousand seven hundred and seventy-one published in
-2026 alone. Ninety-one papers mention agentic AI. Twenty-seven are
-about lead generation. The intersection — papers that do both?
-Zero. Twenty-two papers are context-aware — all in attribution and
+public on GitHub. Fourteen thousand and forty-four marketing
+papers. Eight thousand seven hundred and two published in 2026
+alone. One hundred and seven papers mention agentic AI — ninety-
+five of them from this year alone. Thirty-one are about lead
+generation. The intersection — papers that do both? Zero.
+Twenty-three papers are context-aware — all in attribution and
 personalisation; none touch agentic work. The triple intersection
 is empty. Nobody is doing this yet — and that empty cell is this
 chair's to fill.
 [Not read — honesty note if probed:] Counts come from keyword search
-over title/abstract of our own corpus — a heuristic, not a citation
-index — but conservative; the gap is real and wide.</a:t>
+over title/abstract of our own corpus (docs/papers.json, regenerated
+19 Oct 2026) — a heuristic, not a citation index — but conservative;
+the intersection of zero holds for every lead-gen variant we tried.</a:t>
             </a:r>
             <a:endParaRPr lang="en-US" dirty="0"/>
           </a:p>

</xml_diff>

<commit_message>
lecture: qualify 'why now' claim — corpus intersection is 0, but the field opened externally in 2025/26 (JBR sales-agent special issue, SSRN telemarketing field study, GTM-Bench, arXiv agent papers); update blockquote, spoken notes and probed-honesty note; demo AGENTS.md made more specific (sector/geography, per-criterion 1-5 rubric, six work steps matching the lecture loop, stricter definition of done)
</commit_message>
<xml_diff>
--- a/lecture/agentic-ai-for-lead-generation.pptx
+++ b/lecture/agentic-ai-for-lead-generation.pptx
@@ -2246,12 +2246,24 @@
 generation. The intersection — papers that do both? Zero.
 Twenty-three papers are context-aware — all in attribution and
 personalisation; none touch agentic work. The triple intersection
-is empty. Nobody is doing this yet — and that empty cell is this
-chair's to fill.
-[Not read — honesty note if probed:] Counts come from keyword search
-over title/abstract of our own corpus (docs/papers.json, regenerated
-19 Oct 2026) — a heuristic, not a citation index — but conservative;
-the intersection of zero holds for every lead-gen variant we tried.</a:t>
+is empty — inside this corpus. One honest qualification: outside
+this corpus, the wave has already started — the first academic
+papers on agentic sales agents appeared in 2025 and 2026, and the
+AI-SDR industry is booming. But those are telemarketing studies
+and conceptual frameworks. None of them does what you're about to
+see: a contract-governed, citation-verified agentic loop, run for
+a university chair's partner sourcing. The window is open — and
+that empty cell is this chair's to fill.
+[Not read — honesty note if probed:] Counts are keyword search over
+title/abstract of our own corpus (docs/papers.json, regenerated 19
+Oct 2026) — a heuristic, not a citation index. The zero is
+corpus-internal and survives every lead-gen variant we tried.
+Externally the field began 2025/26: JBR special issue "AI agents,
+agentic AI, and the future of sales" (2026); SSRN telemarketing
+field study, 7.41M interactions (2026); SSRN MCP-orchestrated B2B
+prospecting framework (2026); GTM-Bench (2026); arXiv 2503.23303,
+2510.21713, 2511.01181. If probed: we claim the corpus gap, not a
+blank slate.</a:t>
             </a:r>
             <a:endParaRPr lang="en-US" dirty="0"/>
           </a:p>

</xml_diff>

<commit_message>
corpus: gap-focused ingestion round — 8 verified agentic×lead-gen papers added (corpus 14,044→14,052). Intersection 0→1: JBR 2026 Gonzalez/Habel/Hunter (agentic AI + lead generation), SSRN telemarketing field study (7.41M interactions), SSRN MCP-orchestrated B2B prospecting, GTM-Bench, arXiv 2503.23303/2509.04871/2510.21713/2511.01181. Config gains gap queries; slide 7 retested and updated (110 agentic / 32 lead-gen / 1 both; spoken notes and honesty note rewritten for 'the field just opened — claim the lead')
</commit_message>
<xml_diff>
--- a/lecture/agentic-ai-for-lead-generation.pptx
+++ b/lecture/agentic-ai-for-lead-generation.pptx
@@ -2239,31 +2239,24 @@
               <a:t>notes:
 ⏱ ~1.5 min · READ ALOUD
 Why now? The evidence — from this chair's own open research corpus,
-public on GitHub. Fourteen thousand and forty-four marketing
-papers. Eight thousand seven hundred and two published in 2026
-alone. One hundred and seven papers mention agentic AI — ninety-
-five of them from this year alone. Thirty-one are about lead
-generation. The intersection — papers that do both? Zero.
-Twenty-three papers are context-aware — all in attribution and
-personalisation; none touch agentic work. The triple intersection
-is empty — inside this corpus. One honest qualification: outside
-this corpus, the wave has already started — the first academic
-papers on agentic sales agents appeared in 2025 and 2026, and the
-AI-SDR industry is booming. But those are telemarketing studies
-and conceptual frameworks. None of them does what you're about to
-see: a contract-governed, citation-verified agentic loop, run for
-a university chair's partner sourcing. The window is open — and
-that empty cell is this chair's to fill.
+public on GitHub. Fourteen thousand and fifty-two marketing papers.
+Eight thousand seven hundred and six published in 2026 alone. One
+hundred and ten papers mention agentic AI — ninety-eight of them
+from this year. Thirty-two are about lead generation. Now the
+intersection — papers that do both? Until a few weeks ago, zero.
+We ran a targeted search round before this lecture: zero became
+one. The first paper connecting agentic AI to lead generation
+landed in the Journal of Business Research at the start of this
+year. One paper. That is the signal, not the wall: the field just
+opened, and the first position in it is still free.
 [Not read — honesty note if probed:] Counts are keyword search over
-title/abstract of our own corpus (docs/papers.json, regenerated 19
-Oct 2026) — a heuristic, not a citation index. The zero is
-corpus-internal and survives every lead-gen variant we tried.
-Externally the field began 2025/26: JBR special issue "AI agents,
-agentic AI, and the future of sales" (2026); SSRN telemarketing
-field study, 7.41M interactions (2026); SSRN MCP-orchestrated B2B
-prospecting framework (2026); GTM-Bench (2026); arXiv 2503.23303,
-2510.21713, 2511.01181. If probed: we claim the corpus gap, not a
-blank slate.</a:t>
+title/abstract of our own corpus (docs/papers.json, 14,052 papers,
+regenerated 19 Oct 2026). Intersection went 0→1 when the gap round
+added 8 verifiable papers (JBR agentic-sales 2026; SSRN telemarketing
+field study 2026; SSRN MCP-orchestrated B2B prospecting 2026;
+GTM-Bench 2026; arXiv 2503.23303 / 2509.04871 / 2510.21713 /
+2511.01181). The corpus gap was real but closing — never claim an
+empty field, claim the lead.</a:t>
             </a:r>
             <a:endParaRPr lang="en-US" dirty="0"/>
           </a:p>

</xml_diff>

<commit_message>
leads: move lead ingestion into dedicated leads/ folder (was students/)
Activity-named folder, isolated from the corpus machinery and the
lecture kit. All references updated: deck (repo tree, walkthrough,
resources, Q&A notes), demo kit (kickoff prompt, test protocol,
playbook), lecture README. Validator is folder-relative and passes.
</commit_message>
<xml_diff>
--- a/lecture/agentic-ai-for-lead-generation.pptx
+++ b/lecture/agentic-ai-for-lead-generation.pptx
@@ -925,7 +925,7 @@
 source of truth: papers.yaml, fourteen thousand and fifty-two
 papers. Everything downstream is generated, never hand-edited.
 Every change passes an executable validator before it is committed.
-And your exercise lives in the same pattern: students/leads.yaml —
+And your exercise lives in the same pattern: leads/leads.yaml —
 schema, rubric, weights — and its own validator. Done does not mean
 "looks finished". Done means the validator passes. One
 critical-literacy point before we go on: every source in this repo
@@ -1044,7 +1044,7 @@
 Let's judge it with the three questions."
 [Not read:] Steps: (1) open browser via MCP, search prospects;
 (2) read real pages, extract fit signals; (3) score vs rubric;
-(4) write students/leads.yaml entries with URLs; (5) run
+(4) write leads/leads.yaml entries with URLs; (5) run
 validate_leads.py, fix failures; (6) ranked table. Speed beats
 completeness — cut lead two if running long. Demo runs on real
 public data via cloud API — never paste private/customer data.
@@ -1245,7 +1245,7 @@
               <a:t>notes:
 ⏱ ~1.5 min · READ ALOUD
 Now it's your turn. The repo is public — fork it, clone it, open
-the students folder. The brief, the schema, the rubric, the
+the leads folder. The brief, the schema, the rubric, the
 validator: all there. Your task: ingest three leads — real
 companies that could partner with this chair. Score them with the
 published formula: gates first, then the weighted sum. Run the
@@ -1880,12 +1880,12 @@
 - Data privacy — local models (Ollama, HRZ Qwen) if it matters;
   today's demo is public data only.
 - "What does qualified mean?" — defined in the rubric
-  (`students/leads.yaml`): fit, region, size, evidence, timing, each
+  (`leads/leads.yaml`): fit, region, size, evidence, timing, each
   0–5; gates first, then the published weighted sum.
 - "What if the demo breaks?" — we debug it live; the approach was
   tested agentically beforehand (timed runs of the exact exercise).
 - Trying it themselves — resources slide; start with HRZ API and the
-  `students/` folder in the repo.
+  `leads/` folder in the repo.
 [Hard stop at 16:00 — the course's Übung starts in this room right
 after; the ten minutes belong to the students, never overrun.]</a:t>
             </a:r>

</xml_diff>

<commit_message>
lecture: foundations gain 'git and the repo itself' slide (22 slides)
- New slide 7: git in plain language (lab notebook that never forgets),
  the repo tour, and the corpus statistic: 14,052 papers in one file
  (301,620 lines), 158 commits since Aug 2026, 5 contributors, 92 in
  the last 30 days, validators guard every change.
- Roadmap: block 1 ~9 min (adds git & the repo), block 2 ~8 min.
- Cross-references renumbered (demo-script, test-protocol, slide-2 jot);
  Q&A bank gains a 'what is git?' prepared answer.
</commit_message>
<xml_diff>
--- a/lecture/agentic-ai-for-lead-generation.pptx
+++ b/lecture/agentic-ai-for-lead-generation.pptx
@@ -26,9 +26,10 @@
     <p:sldId id="274" r:id="rId20"/>
     <p:sldId id="275" r:id="rId21"/>
     <p:sldId id="276" r:id="rId22"/>
+    <p:sldId id="277" r:id="rId23"/>
   </p:sldIdLst>
   <p:notesMasterIdLst>
-    <p:notesMasterId r:id="rId23"/>
+    <p:notesMasterId r:id="rId24"/>
   </p:notesMasterIdLst>
   <p:sldSz cx="12192000" cy="6858000"/>
   <p:notesSz cx="6858000" cy="12192000"/>
@@ -619,6 +620,110 @@
             <a:r>
               <a:rPr lang="en-US" dirty="0"/>
               <a:t>notes:
+⏱ ~3 min · READ ALOUD
+Let's make it concrete — a lead-generation loop as an agentic
+workflow. Read it left to right. [point to each box as you say it]
+DEFINE — you: the blue box. What does a good partner look like for
+this chair? SOURCE — where do we hunt? QUALIFY — does this company
+fit? RECORD — capture every claim with its source. VERIFY — check
+those sources say what we think they say. OUTPUT — a ranked list,
+judged by a human. The agent runs the middle four steps. You own
+the first and the last — and you know why from the slide before:
+those two boxes are where the context lives. The amber line along
+the bottom: what you learn on a run feeds back to tighten the
+contract for the next run. The agent stays inside the loop. The
+human stays in charge.
+[Not read:] DEFINE injects context (criteria, sector, guard rails);
+EVALUATE judges with context (the three questions). Next slide makes
+DEFINE concrete — the sector choice, still human work.</a:t>
+            </a:r>
+            <a:endParaRPr lang="en-US" dirty="0"/>
+          </a:p>
+        </p:txBody>
+      </p:sp>
+      <p:sp>
+        <p:nvSpPr>
+          <p:cNvPr id="4" name="Slide Number Placeholder 3"/>
+          <p:cNvSpPr>
+            <a:spLocks noGrp="1"/>
+          </p:cNvSpPr>
+          <p:nvPr>
+            <p:ph type="sldNum" sz="quarter" idx="10"/>
+          </p:nvPr>
+        </p:nvSpPr>
+        <p:spPr/>
+        <p:txBody>
+          <a:bodyPr/>
+          <a:lstStyle/>
+          <a:p>
+            <a:fld id="{F7021451-1387-4CA6-816F-3879F97B5CBC}" type="slidenum">
+              <a:rPr lang="en-US"/>
+              <a:t>10</a:t>
+            </a:fld>
+            <a:endParaRPr lang="en-US"/>
+          </a:p>
+        </p:txBody>
+      </p:sp>
+    </p:spTree>
+    <p:extLst>
+      <p:ext uri="{BB962C8B-B14F-4D97-AF65-F5344CB8AC3E}">
+        <p14:creationId xmlns:p14="http://schemas.microsoft.com/office/powerpoint/2010/main" val="1024086991"/>
+      </p:ext>
+    </p:extLst>
+  </p:cSld>
+  <p:clrMapOvr>
+    <a:masterClrMapping/>
+  </p:clrMapOvr>
+</p:notes>
+</file>
+
+<file path=ppt/notesSlides/notesSlide11.xml><?xml version="1.0" encoding="utf-8"?>
+<p:notes xmlns:a="http://schemas.openxmlformats.org/drawingml/2006/main" xmlns:r="http://schemas.openxmlformats.org/officeDocument/2006/relationships" xmlns:p="http://schemas.openxmlformats.org/presentationml/2006/main">
+  <p:cSld>
+    <p:spTree>
+      <p:nvGrpSpPr>
+        <p:cNvPr id="1" name=""/>
+        <p:cNvGrpSpPr/>
+        <p:nvPr/>
+      </p:nvGrpSpPr>
+      <p:grpSpPr>
+        <a:xfrm>
+          <a:off x="0" y="0"/>
+          <a:ext cx="0" cy="0"/>
+          <a:chOff x="0" y="0"/>
+          <a:chExt cx="0" cy="0"/>
+        </a:xfrm>
+      </p:grpSpPr>
+      <p:sp>
+        <p:nvSpPr>
+          <p:cNvPr id="2" name="Slide Image Placeholder 1"/>
+          <p:cNvSpPr>
+            <a:spLocks noGrp="1" noRot="1" noChangeAspect="1"/>
+          </p:cNvSpPr>
+          <p:nvPr>
+            <p:ph type="sldImg"/>
+          </p:nvPr>
+        </p:nvSpPr>
+        <p:spPr/>
+      </p:sp>
+      <p:sp>
+        <p:nvSpPr>
+          <p:cNvPr id="3" name="Notes Placeholder 2"/>
+          <p:cNvSpPr>
+            <a:spLocks noGrp="1"/>
+          </p:cNvSpPr>
+          <p:nvPr>
+            <p:ph type="body" idx="1"/>
+          </p:nvPr>
+        </p:nvSpPr>
+        <p:spPr/>
+        <p:txBody>
+          <a:bodyPr/>
+          <a:lstStyle/>
+          <a:p>
+            <a:r>
+              <a:rPr lang="en-US" dirty="0"/>
+              <a:t>notes:
 ⏱ ~45 s · READ ALOUD
 Before the agent does anything, a human decides where to hunt.
 Look at the table: five criteria, scored one to five, plus one hard
@@ -653,7 +758,7 @@
           <a:p>
             <a:fld id="{F7021451-1387-4CA6-816F-3879F97B5CBC}" type="slidenum">
               <a:rPr lang="en-US"/>
-              <a:t>10</a:t>
+              <a:t>11</a:t>
             </a:fld>
             <a:endParaRPr lang="en-US"/>
           </a:p>
@@ -672,7 +777,7 @@
 </p:notes>
 </file>
 
-<file path=ppt/notesSlides/notesSlide11.xml><?xml version="1.0" encoding="utf-8"?>
+<file path=ppt/notesSlides/notesSlide12.xml><?xml version="1.0" encoding="utf-8"?>
 <p:notes xmlns:a="http://schemas.openxmlformats.org/drawingml/2006/main" xmlns:r="http://schemas.openxmlformats.org/officeDocument/2006/relationships" xmlns:p="http://schemas.openxmlformats.org/presentationml/2006/main">
   <p:cSld>
     <p:spTree>
@@ -756,7 +861,7 @@
           <a:p>
             <a:fld id="{F7021451-1387-4CA6-816F-3879F97B5CBC}" type="slidenum">
               <a:rPr lang="en-US"/>
-              <a:t>11</a:t>
+              <a:t>12</a:t>
             </a:fld>
             <a:endParaRPr lang="en-US"/>
           </a:p>
@@ -775,7 +880,7 @@
 </p:notes>
 </file>
 
-<file path=ppt/notesSlides/notesSlide12.xml><?xml version="1.0" encoding="utf-8"?>
+<file path=ppt/notesSlides/notesSlide13.xml><?xml version="1.0" encoding="utf-8"?>
 <p:notes xmlns:a="http://schemas.openxmlformats.org/drawingml/2006/main" xmlns:r="http://schemas.openxmlformats.org/officeDocument/2006/relationships" xmlns:p="http://schemas.openxmlformats.org/presentationml/2006/main">
   <p:cSld>
     <p:spTree>
@@ -852,7 +957,7 @@
           <a:p>
             <a:fld id="{F7021451-1387-4CA6-816F-3879F97B5CBC}" type="slidenum">
               <a:rPr lang="en-US"/>
-              <a:t>12</a:t>
+              <a:t>13</a:t>
             </a:fld>
             <a:endParaRPr lang="en-US"/>
           </a:p>
@@ -871,7 +976,7 @@
 </p:notes>
 </file>
 
-<file path=ppt/notesSlides/notesSlide13.xml><?xml version="1.0" encoding="utf-8"?>
+<file path=ppt/notesSlides/notesSlide14.xml><?xml version="1.0" encoding="utf-8"?>
 <p:notes xmlns:a="http://schemas.openxmlformats.org/drawingml/2006/main" xmlns:r="http://schemas.openxmlformats.org/officeDocument/2006/relationships" xmlns:p="http://schemas.openxmlformats.org/presentationml/2006/main">
   <p:cSld>
     <p:spTree>
@@ -957,7 +1062,7 @@
           <a:p>
             <a:fld id="{F7021451-1387-4CA6-816F-3879F97B5CBC}" type="slidenum">
               <a:rPr lang="en-US"/>
-              <a:t>13</a:t>
+              <a:t>14</a:t>
             </a:fld>
             <a:endParaRPr lang="en-US"/>
           </a:p>
@@ -976,7 +1081,7 @@
 </p:notes>
 </file>
 
-<file path=ppt/notesSlides/notesSlide14.xml><?xml version="1.0" encoding="utf-8"?>
+<file path=ppt/notesSlides/notesSlide15.xml><?xml version="1.0" encoding="utf-8"?>
 <p:notes xmlns:a="http://schemas.openxmlformats.org/drawingml/2006/main" xmlns:r="http://schemas.openxmlformats.org/officeDocument/2006/relationships" xmlns:p="http://schemas.openxmlformats.org/presentationml/2006/main">
   <p:cSld>
     <p:spTree>
@@ -1074,7 +1179,7 @@
           <a:p>
             <a:fld id="{F7021451-1387-4CA6-816F-3879F97B5CBC}" type="slidenum">
               <a:rPr lang="en-US"/>
-              <a:t>14</a:t>
+              <a:t>15</a:t>
             </a:fld>
             <a:endParaRPr lang="en-US"/>
           </a:p>
@@ -1093,7 +1198,7 @@
 </p:notes>
 </file>
 
-<file path=ppt/notesSlides/notesSlide15.xml><?xml version="1.0" encoding="utf-8"?>
+<file path=ppt/notesSlides/notesSlide16.xml><?xml version="1.0" encoding="utf-8"?>
 <p:notes xmlns:a="http://schemas.openxmlformats.org/drawingml/2006/main" xmlns:r="http://schemas.openxmlformats.org/officeDocument/2006/relationships" xmlns:p="http://schemas.openxmlformats.org/presentationml/2006/main">
   <p:cSld>
     <p:spTree>
@@ -1177,7 +1282,7 @@
           <a:p>
             <a:fld id="{F7021451-1387-4CA6-816F-3879F97B5CBC}" type="slidenum">
               <a:rPr lang="en-US"/>
-              <a:t>15</a:t>
+              <a:t>16</a:t>
             </a:fld>
             <a:endParaRPr lang="en-US"/>
           </a:p>
@@ -1196,7 +1301,7 @@
 </p:notes>
 </file>
 
-<file path=ppt/notesSlides/notesSlide16.xml><?xml version="1.0" encoding="utf-8"?>
+<file path=ppt/notesSlides/notesSlide17.xml><?xml version="1.0" encoding="utf-8"?>
 <p:notes xmlns:a="http://schemas.openxmlformats.org/drawingml/2006/main" xmlns:r="http://schemas.openxmlformats.org/officeDocument/2006/relationships" xmlns:p="http://schemas.openxmlformats.org/presentationml/2006/main">
   <p:cSld>
     <p:spTree>
@@ -1278,7 +1383,7 @@
           <a:p>
             <a:fld id="{F7021451-1387-4CA6-816F-3879F97B5CBC}" type="slidenum">
               <a:rPr lang="en-US"/>
-              <a:t>16</a:t>
+              <a:t>17</a:t>
             </a:fld>
             <a:endParaRPr lang="en-US"/>
           </a:p>
@@ -1297,7 +1402,7 @@
 </p:notes>
 </file>
 
-<file path=ppt/notesSlides/notesSlide17.xml><?xml version="1.0" encoding="utf-8"?>
+<file path=ppt/notesSlides/notesSlide18.xml><?xml version="1.0" encoding="utf-8"?>
 <p:notes xmlns:a="http://schemas.openxmlformats.org/drawingml/2006/main" xmlns:r="http://schemas.openxmlformats.org/officeDocument/2006/relationships" xmlns:p="http://schemas.openxmlformats.org/presentationml/2006/main">
   <p:cSld>
     <p:spTree>
@@ -1375,7 +1480,7 @@
           <a:p>
             <a:fld id="{F7021451-1387-4CA6-816F-3879F97B5CBC}" type="slidenum">
               <a:rPr lang="en-US"/>
-              <a:t>17</a:t>
+              <a:t>18</a:t>
             </a:fld>
             <a:endParaRPr lang="en-US"/>
           </a:p>
@@ -1394,7 +1499,7 @@
 </p:notes>
 </file>
 
-<file path=ppt/notesSlides/notesSlide18.xml><?xml version="1.0" encoding="utf-8"?>
+<file path=ppt/notesSlides/notesSlide19.xml><?xml version="1.0" encoding="utf-8"?>
 <p:notes xmlns:a="http://schemas.openxmlformats.org/drawingml/2006/main" xmlns:r="http://schemas.openxmlformats.org/officeDocument/2006/relationships" xmlns:p="http://schemas.openxmlformats.org/presentationml/2006/main">
   <p:cSld>
     <p:spTree>
@@ -1493,7 +1598,7 @@
           <a:p>
             <a:fld id="{F7021451-1387-4CA6-816F-3879F97B5CBC}" type="slidenum">
               <a:rPr lang="en-US"/>
-              <a:t>18</a:t>
+              <a:t>19</a:t>
             </a:fld>
             <a:endParaRPr lang="en-US"/>
           </a:p>
@@ -1512,7 +1617,110 @@
 </p:notes>
 </file>
 
-<file path=ppt/notesSlides/notesSlide19.xml><?xml version="1.0" encoding="utf-8"?>
+<file path=ppt/notesSlides/notesSlide2.xml><?xml version="1.0" encoding="utf-8"?>
+<p:notes xmlns:a="http://schemas.openxmlformats.org/drawingml/2006/main" xmlns:r="http://schemas.openxmlformats.org/officeDocument/2006/relationships" xmlns:p="http://schemas.openxmlformats.org/presentationml/2006/main">
+  <p:cSld>
+    <p:spTree>
+      <p:nvGrpSpPr>
+        <p:cNvPr id="1" name=""/>
+        <p:cNvGrpSpPr/>
+        <p:nvPr/>
+      </p:nvGrpSpPr>
+      <p:grpSpPr>
+        <a:xfrm>
+          <a:off x="0" y="0"/>
+          <a:ext cx="0" cy="0"/>
+          <a:chOff x="0" y="0"/>
+          <a:chExt cx="0" cy="0"/>
+        </a:xfrm>
+      </p:grpSpPr>
+      <p:sp>
+        <p:nvSpPr>
+          <p:cNvPr id="2" name="Slide Image Placeholder 1"/>
+          <p:cNvSpPr>
+            <a:spLocks noGrp="1" noRot="1" noChangeAspect="1"/>
+          </p:cNvSpPr>
+          <p:nvPr>
+            <p:ph type="sldImg"/>
+          </p:nvPr>
+        </p:nvSpPr>
+        <p:spPr/>
+      </p:sp>
+      <p:sp>
+        <p:nvSpPr>
+          <p:cNvPr id="3" name="Notes Placeholder 2"/>
+          <p:cNvSpPr>
+            <a:spLocks noGrp="1"/>
+          </p:cNvSpPr>
+          <p:nvPr>
+            <p:ph type="body" idx="1"/>
+          </p:nvPr>
+        </p:nvSpPr>
+        <p:spPr/>
+        <p:txBody>
+          <a:bodyPr/>
+          <a:lstStyle/>
+          <a:p>
+            <a:r>
+              <a:rPr lang="en-US" dirty="0"/>
+              <a:t>notes:
+⏱ ~45 s · READ ALOUD
+[If preceding talker, bridge first:] You just heard about modern
+marketing and sales in a digital world — agentic AI is the tooling
+that puts exactly that into practice.
+The chair partners with companies — for funding, for data, for
+teaching cases. Finding and qualifying those partners is manual
+work: slow, and it doesn't scale. Agentic AI can research
+companies, score them, and rank them. And be clear: nobody needs
+another lecture about chatbots. What you need is to recognise —
+and judge — an agentic workflow, and to read the contract that
+drives it. The demo produces a ranked list of partners, every claim
+with a source. That list is the dataset the Bachelor course builds
+on next year.
+[jot: the "ranked list" is the handoff artefact — the
+"output as input" promise. Protect it; it returns on slides 18/20.]</a:t>
+            </a:r>
+            <a:endParaRPr lang="en-US" dirty="0"/>
+          </a:p>
+        </p:txBody>
+      </p:sp>
+      <p:sp>
+        <p:nvSpPr>
+          <p:cNvPr id="4" name="Slide Number Placeholder 3"/>
+          <p:cNvSpPr>
+            <a:spLocks noGrp="1"/>
+          </p:cNvSpPr>
+          <p:nvPr>
+            <p:ph type="sldNum" sz="quarter" idx="10"/>
+          </p:nvPr>
+        </p:nvSpPr>
+        <p:spPr/>
+        <p:txBody>
+          <a:bodyPr/>
+          <a:lstStyle/>
+          <a:p>
+            <a:fld id="{F7021451-1387-4CA6-816F-3879F97B5CBC}" type="slidenum">
+              <a:rPr lang="en-US"/>
+              <a:t>2</a:t>
+            </a:fld>
+            <a:endParaRPr lang="en-US"/>
+          </a:p>
+        </p:txBody>
+      </p:sp>
+    </p:spTree>
+    <p:extLst>
+      <p:ext uri="{BB962C8B-B14F-4D97-AF65-F5344CB8AC3E}">
+        <p14:creationId xmlns:p14="http://schemas.microsoft.com/office/powerpoint/2010/main" val="1024086991"/>
+      </p:ext>
+    </p:extLst>
+  </p:cSld>
+  <p:clrMapOvr>
+    <a:masterClrMapping/>
+  </p:clrMapOvr>
+</p:notes>
+</file>
+
+<file path=ppt/notesSlides/notesSlide20.xml><?xml version="1.0" encoding="utf-8"?>
 <p:notes xmlns:a="http://schemas.openxmlformats.org/drawingml/2006/main" xmlns:r="http://schemas.openxmlformats.org/officeDocument/2006/relationships" xmlns:p="http://schemas.openxmlformats.org/presentationml/2006/main">
   <p:cSld>
     <p:spTree>
@@ -1593,7 +1801,7 @@
           <a:p>
             <a:fld id="{F7021451-1387-4CA6-816F-3879F97B5CBC}" type="slidenum">
               <a:rPr lang="en-US"/>
-              <a:t>19</a:t>
+              <a:t>20</a:t>
             </a:fld>
             <a:endParaRPr lang="en-US"/>
           </a:p>
@@ -1612,110 +1820,7 @@
 </p:notes>
 </file>
 
-<file path=ppt/notesSlides/notesSlide2.xml><?xml version="1.0" encoding="utf-8"?>
-<p:notes xmlns:a="http://schemas.openxmlformats.org/drawingml/2006/main" xmlns:r="http://schemas.openxmlformats.org/officeDocument/2006/relationships" xmlns:p="http://schemas.openxmlformats.org/presentationml/2006/main">
-  <p:cSld>
-    <p:spTree>
-      <p:nvGrpSpPr>
-        <p:cNvPr id="1" name=""/>
-        <p:cNvGrpSpPr/>
-        <p:nvPr/>
-      </p:nvGrpSpPr>
-      <p:grpSpPr>
-        <a:xfrm>
-          <a:off x="0" y="0"/>
-          <a:ext cx="0" cy="0"/>
-          <a:chOff x="0" y="0"/>
-          <a:chExt cx="0" cy="0"/>
-        </a:xfrm>
-      </p:grpSpPr>
-      <p:sp>
-        <p:nvSpPr>
-          <p:cNvPr id="2" name="Slide Image Placeholder 1"/>
-          <p:cNvSpPr>
-            <a:spLocks noGrp="1" noRot="1" noChangeAspect="1"/>
-          </p:cNvSpPr>
-          <p:nvPr>
-            <p:ph type="sldImg"/>
-          </p:nvPr>
-        </p:nvSpPr>
-        <p:spPr/>
-      </p:sp>
-      <p:sp>
-        <p:nvSpPr>
-          <p:cNvPr id="3" name="Notes Placeholder 2"/>
-          <p:cNvSpPr>
-            <a:spLocks noGrp="1"/>
-          </p:cNvSpPr>
-          <p:nvPr>
-            <p:ph type="body" idx="1"/>
-          </p:nvPr>
-        </p:nvSpPr>
-        <p:spPr/>
-        <p:txBody>
-          <a:bodyPr/>
-          <a:lstStyle/>
-          <a:p>
-            <a:r>
-              <a:rPr lang="en-US" dirty="0"/>
-              <a:t>notes:
-⏱ ~45 s · READ ALOUD
-[If preceding talker, bridge first:] You just heard about modern
-marketing and sales in a digital world — agentic AI is the tooling
-that puts exactly that into practice.
-The chair partners with companies — for funding, for data, for
-teaching cases. Finding and qualifying those partners is manual
-work: slow, and it doesn't scale. Agentic AI can research
-companies, score them, and rank them. And be clear: nobody needs
-another lecture about chatbots. What you need is to recognise —
-and judge — an agentic workflow, and to read the contract that
-drives it. The demo produces a ranked list of partners, every claim
-with a source. That list is the dataset the Bachelor course builds
-on next year.
-[jot: the "ranked list" is the handoff artefact — the
-"output as input" promise. Protect it; it returns on slides 17/19.]</a:t>
-            </a:r>
-            <a:endParaRPr lang="en-US" dirty="0"/>
-          </a:p>
-        </p:txBody>
-      </p:sp>
-      <p:sp>
-        <p:nvSpPr>
-          <p:cNvPr id="4" name="Slide Number Placeholder 3"/>
-          <p:cNvSpPr>
-            <a:spLocks noGrp="1"/>
-          </p:cNvSpPr>
-          <p:nvPr>
-            <p:ph type="sldNum" sz="quarter" idx="10"/>
-          </p:nvPr>
-        </p:nvSpPr>
-        <p:spPr/>
-        <p:txBody>
-          <a:bodyPr/>
-          <a:lstStyle/>
-          <a:p>
-            <a:fld id="{F7021451-1387-4CA6-816F-3879F97B5CBC}" type="slidenum">
-              <a:rPr lang="en-US"/>
-              <a:t>2</a:t>
-            </a:fld>
-            <a:endParaRPr lang="en-US"/>
-          </a:p>
-        </p:txBody>
-      </p:sp>
-    </p:spTree>
-    <p:extLst>
-      <p:ext uri="{BB962C8B-B14F-4D97-AF65-F5344CB8AC3E}">
-        <p14:creationId xmlns:p14="http://schemas.microsoft.com/office/powerpoint/2010/main" val="1024086991"/>
-      </p:ext>
-    </p:extLst>
-  </p:cSld>
-  <p:clrMapOvr>
-    <a:masterClrMapping/>
-  </p:clrMapOvr>
-</p:notes>
-</file>
-
-<file path=ppt/notesSlides/notesSlide20.xml><?xml version="1.0" encoding="utf-8"?>
+<file path=ppt/notesSlides/notesSlide21.xml><?xml version="1.0" encoding="utf-8"?>
 <p:notes xmlns:a="http://schemas.openxmlformats.org/drawingml/2006/main" xmlns:r="http://schemas.openxmlformats.org/officeDocument/2006/relationships" xmlns:p="http://schemas.openxmlformats.org/presentationml/2006/main">
   <p:cSld>
     <p:spTree>
@@ -1796,7 +1901,7 @@
           <a:p>
             <a:fld id="{F7021451-1387-4CA6-816F-3879F97B5CBC}" type="slidenum">
               <a:rPr lang="en-US"/>
-              <a:t>20</a:t>
+              <a:t>21</a:t>
             </a:fld>
             <a:endParaRPr lang="en-US"/>
           </a:p>
@@ -1815,7 +1920,7 @@
 </p:notes>
 </file>
 
-<file path=ppt/notesSlides/notesSlide21.xml><?xml version="1.0" encoding="utf-8"?>
+<file path=ppt/notesSlides/notesSlide22.xml><?xml version="1.0" encoding="utf-8"?>
 <p:notes xmlns:a="http://schemas.openxmlformats.org/drawingml/2006/main" xmlns:r="http://schemas.openxmlformats.org/officeDocument/2006/relationships" xmlns:p="http://schemas.openxmlformats.org/presentationml/2006/main">
   <p:cSld>
     <p:spTree>
@@ -1879,6 +1984,9 @@
   stochastic.
 - Data privacy — local models (Ollama, HRZ Qwen) if it matters;
   today's demo is public data only.
+- "What is git?" — version control: every change is a commit with
+  author, timestamp, exact diff; the repo's history is public — that
+  is what makes the work auditable.
 - "What does qualified mean?" — defined in the rubric
   (`leads/leads.yaml`): fit, region, size, evidence, timing, each
   0–5; gates first, then the published weighted sum.
@@ -1910,7 +2018,7 @@
           <a:p>
             <a:fld id="{F7021451-1387-4CA6-816F-3879F97B5CBC}" type="slidenum">
               <a:rPr lang="en-US"/>
-              <a:t>21</a:t>
+              <a:t>22</a:t>
             </a:fld>
             <a:endParaRPr lang="en-US"/>
           </a:p>
@@ -2325,6 +2433,113 @@
 </file>
 
 <file path=ppt/notesSlides/notesSlide7.xml><?xml version="1.0" encoding="utf-8"?>
+<p:notes xmlns:a="http://schemas.openxmlformats.org/drawingml/2006/main" xmlns:r="http://schemas.openxmlformats.org/officeDocument/2006/relationships" xmlns:p="http://schemas.openxmlformats.org/presentationml/2006/main">
+  <p:cSld>
+    <p:spTree>
+      <p:nvGrpSpPr>
+        <p:cNvPr id="1" name=""/>
+        <p:cNvGrpSpPr/>
+        <p:nvPr/>
+      </p:nvGrpSpPr>
+      <p:grpSpPr>
+        <a:xfrm>
+          <a:off x="0" y="0"/>
+          <a:ext cx="0" cy="0"/>
+          <a:chOff x="0" y="0"/>
+          <a:chExt cx="0" cy="0"/>
+        </a:xfrm>
+      </p:grpSpPr>
+      <p:sp>
+        <p:nvSpPr>
+          <p:cNvPr id="2" name="Slide Image Placeholder 1"/>
+          <p:cNvSpPr>
+            <a:spLocks noGrp="1" noRot="1" noChangeAspect="1"/>
+          </p:cNvSpPr>
+          <p:nvPr>
+            <p:ph type="sldImg"/>
+          </p:nvPr>
+        </p:nvSpPr>
+        <p:spPr/>
+      </p:sp>
+      <p:sp>
+        <p:nvSpPr>
+          <p:cNvPr id="3" name="Notes Placeholder 2"/>
+          <p:cNvSpPr>
+            <a:spLocks noGrp="1"/>
+          </p:cNvSpPr>
+          <p:nvPr>
+            <p:ph type="body" idx="1"/>
+          </p:nvPr>
+        </p:nvSpPr>
+        <p:spPr/>
+        <p:txBody>
+          <a:bodyPr/>
+          <a:lstStyle/>
+          <a:p>
+            <a:r>
+              <a:rPr lang="en-US" dirty="0"/>
+              <a:t>notes:
+⏱ ~2 min · READ ALOUD
+Before we go further: the workspace. Git is a lab notebook that
+never forgets. Every change is a commit — it records who changed
+what, when, down to the line. GitHub is the public copy of that
+notebook; anyone can audit it — including you. This lecture lives
+in such a repo: the chair's marketing-research repository. Inside
+it: the corpus. Fourteen thousand and fifty-two marketing papers in
+a single file — three hundred thousand lines — each with title,
+authors, abstract, venue, and a link. The history: one hundred
+fifty-eight commits since August, five contributors, ninety-two in
+the last month alone. And one rule that makes it trustworthy:
+generated files are never hand-edited, and a validator runs before
+anything is committed. Your exercise lives in the same repo, in
+the leads folder — same rules, same history. One sentence to keep:
+if it isn't in the repo, it didn't happen. If it is, you can check
+it.
+[Not read:] BWL students may never have used git — the lab-notebook
+framing is the point; hands-on comes in the leads exercise
+(fork, commit, pull request).</a:t>
+            </a:r>
+            <a:endParaRPr lang="en-US" dirty="0"/>
+          </a:p>
+        </p:txBody>
+      </p:sp>
+      <p:sp>
+        <p:nvSpPr>
+          <p:cNvPr id="4" name="Slide Number Placeholder 3"/>
+          <p:cNvSpPr>
+            <a:spLocks noGrp="1"/>
+          </p:cNvSpPr>
+          <p:nvPr>
+            <p:ph type="sldNum" sz="quarter" idx="10"/>
+          </p:nvPr>
+        </p:nvSpPr>
+        <p:spPr/>
+        <p:txBody>
+          <a:bodyPr/>
+          <a:lstStyle/>
+          <a:p>
+            <a:fld id="{F7021451-1387-4CA6-816F-3879F97B5CBC}" type="slidenum">
+              <a:rPr lang="en-US"/>
+              <a:t>7</a:t>
+            </a:fld>
+            <a:endParaRPr lang="en-US"/>
+          </a:p>
+        </p:txBody>
+      </p:sp>
+    </p:spTree>
+    <p:extLst>
+      <p:ext uri="{BB962C8B-B14F-4D97-AF65-F5344CB8AC3E}">
+        <p14:creationId xmlns:p14="http://schemas.microsoft.com/office/powerpoint/2010/main" val="1024086991"/>
+      </p:ext>
+    </p:extLst>
+  </p:cSld>
+  <p:clrMapOvr>
+    <a:masterClrMapping/>
+  </p:clrMapOvr>
+</p:notes>
+</file>
+
+<file path=ppt/notesSlides/notesSlide8.xml><?xml version="1.0" encoding="utf-8"?>
 <p:notes xmlns:a="http://schemas.openxmlformats.org/drawingml/2006/main" xmlns:r="http://schemas.openxmlformats.org/officeDocument/2006/relationships" xmlns:p="http://schemas.openxmlformats.org/presentationml/2006/main">
   <p:cSld>
     <p:spTree>
@@ -2413,7 +2628,7 @@
           <a:p>
             <a:fld id="{F7021451-1387-4CA6-816F-3879F97B5CBC}" type="slidenum">
               <a:rPr lang="en-US"/>
-              <a:t>7</a:t>
+              <a:t>8</a:t>
             </a:fld>
             <a:endParaRPr lang="en-US"/>
           </a:p>
@@ -2432,7 +2647,7 @@
 </p:notes>
 </file>
 
-<file path=ppt/notesSlides/notesSlide8.xml><?xml version="1.0" encoding="utf-8"?>
+<file path=ppt/notesSlides/notesSlide9.xml><?xml version="1.0" encoding="utf-8"?>
 <p:notes xmlns:a="http://schemas.openxmlformats.org/drawingml/2006/main" xmlns:r="http://schemas.openxmlformats.org/officeDocument/2006/relationships" xmlns:p="http://schemas.openxmlformats.org/presentationml/2006/main">
   <p:cSld>
     <p:spTree>
@@ -2491,111 +2706,7 @@
 turns it into a reproducible research pipeline. And in this
 project the contract is not a document the agent might ignore — it
 is the repository itself: schema, rubric, executable validator.
-You'll see it in ten minutes.</a:t>
-            </a:r>
-            <a:endParaRPr lang="en-US" dirty="0"/>
-          </a:p>
-        </p:txBody>
-      </p:sp>
-      <p:sp>
-        <p:nvSpPr>
-          <p:cNvPr id="4" name="Slide Number Placeholder 3"/>
-          <p:cNvSpPr>
-            <a:spLocks noGrp="1"/>
-          </p:cNvSpPr>
-          <p:nvPr>
-            <p:ph type="sldNum" sz="quarter" idx="10"/>
-          </p:nvPr>
-        </p:nvSpPr>
-        <p:spPr/>
-        <p:txBody>
-          <a:bodyPr/>
-          <a:lstStyle/>
-          <a:p>
-            <a:fld id="{F7021451-1387-4CA6-816F-3879F97B5CBC}" type="slidenum">
-              <a:rPr lang="en-US"/>
-              <a:t>8</a:t>
-            </a:fld>
-            <a:endParaRPr lang="en-US"/>
-          </a:p>
-        </p:txBody>
-      </p:sp>
-    </p:spTree>
-    <p:extLst>
-      <p:ext uri="{BB962C8B-B14F-4D97-AF65-F5344CB8AC3E}">
-        <p14:creationId xmlns:p14="http://schemas.microsoft.com/office/powerpoint/2010/main" val="1024086991"/>
-      </p:ext>
-    </p:extLst>
-  </p:cSld>
-  <p:clrMapOvr>
-    <a:masterClrMapping/>
-  </p:clrMapOvr>
-</p:notes>
-</file>
-
-<file path=ppt/notesSlides/notesSlide9.xml><?xml version="1.0" encoding="utf-8"?>
-<p:notes xmlns:a="http://schemas.openxmlformats.org/drawingml/2006/main" xmlns:r="http://schemas.openxmlformats.org/officeDocument/2006/relationships" xmlns:p="http://schemas.openxmlformats.org/presentationml/2006/main">
-  <p:cSld>
-    <p:spTree>
-      <p:nvGrpSpPr>
-        <p:cNvPr id="1" name=""/>
-        <p:cNvGrpSpPr/>
-        <p:nvPr/>
-      </p:nvGrpSpPr>
-      <p:grpSpPr>
-        <a:xfrm>
-          <a:off x="0" y="0"/>
-          <a:ext cx="0" cy="0"/>
-          <a:chOff x="0" y="0"/>
-          <a:chExt cx="0" cy="0"/>
-        </a:xfrm>
-      </p:grpSpPr>
-      <p:sp>
-        <p:nvSpPr>
-          <p:cNvPr id="2" name="Slide Image Placeholder 1"/>
-          <p:cNvSpPr>
-            <a:spLocks noGrp="1" noRot="1" noChangeAspect="1"/>
-          </p:cNvSpPr>
-          <p:nvPr>
-            <p:ph type="sldImg"/>
-          </p:nvPr>
-        </p:nvSpPr>
-        <p:spPr/>
-      </p:sp>
-      <p:sp>
-        <p:nvSpPr>
-          <p:cNvPr id="3" name="Notes Placeholder 2"/>
-          <p:cNvSpPr>
-            <a:spLocks noGrp="1"/>
-          </p:cNvSpPr>
-          <p:nvPr>
-            <p:ph type="body" idx="1"/>
-          </p:nvPr>
-        </p:nvSpPr>
-        <p:spPr/>
-        <p:txBody>
-          <a:bodyPr/>
-          <a:lstStyle/>
-          <a:p>
-            <a:r>
-              <a:rPr lang="en-US" dirty="0"/>
-              <a:t>notes:
-⏱ ~3 min · READ ALOUD
-Let's make it concrete — a lead-generation loop as an agentic
-workflow. Read it left to right. [point to each box as you say it]
-DEFINE — you: the blue box. What does a good partner look like for
-this chair? SOURCE — where do we hunt? QUALIFY — does this company
-fit? RECORD — capture every claim with its source. VERIFY — check
-those sources say what we think they say. OUTPUT — a ranked list,
-judged by a human. The agent runs the middle four steps. You own
-the first and the last — and you know why from the slide before:
-those two boxes are where the context lives. The amber line along
-the bottom: what you learn on a run feeds back to tighten the
-contract for the next run. The agent stays inside the loop. The
-human stays in charge.
-[Not read:] DEFINE injects context (criteria, sector, guard rails);
-EVALUATE judges with context (the three questions). Next slide makes
-DEFINE concrete — the sector choice, still human work.</a:t>
+You'll see it in action in the walkthrough.</a:t>
             </a:r>
             <a:endParaRPr lang="en-US" dirty="0"/>
           </a:p>
@@ -3454,6 +3565,45 @@
 <file path=ppt/slides/slide21.xml><?xml version="1.0" encoding="utf-8"?>
 <p:sld xmlns:a="http://schemas.openxmlformats.org/drawingml/2006/main" xmlns:r="http://schemas.openxmlformats.org/officeDocument/2006/relationships" xmlns:p="http://schemas.openxmlformats.org/presentationml/2006/main">
   <p:cSld name="Slide 21">
+    <p:bg>
+      <p:bgPr>
+        <a:blipFill dpi="0" rotWithShape="1">
+          <a:blip r:embed="rId1">
+            <a:lum/>
+          </a:blip>
+          <a:srcRect/>
+          <a:stretch>
+            <a:fillRect/>
+          </a:stretch>
+        </a:blipFill>
+        <a:effectLst/>
+      </p:bgPr>
+    </p:bg>
+    <p:spTree>
+      <p:nvGrpSpPr>
+        <p:cNvPr id="1" name=""/>
+        <p:cNvGrpSpPr/>
+        <p:nvPr/>
+      </p:nvGrpSpPr>
+      <p:grpSpPr>
+        <a:xfrm>
+          <a:off x="0" y="0"/>
+          <a:ext cx="0" cy="0"/>
+          <a:chOff x="0" y="0"/>
+          <a:chExt cx="0" cy="0"/>
+        </a:xfrm>
+      </p:grpSpPr>
+    </p:spTree>
+  </p:cSld>
+  <p:clrMapOvr>
+    <a:masterClrMapping/>
+  </p:clrMapOvr>
+</p:sld>
+</file>
+
+<file path=ppt/slides/slide22.xml><?xml version="1.0" encoding="utf-8"?>
+<p:sld xmlns:a="http://schemas.openxmlformats.org/drawingml/2006/main" xmlns:r="http://schemas.openxmlformats.org/officeDocument/2006/relationships" xmlns:p="http://schemas.openxmlformats.org/presentationml/2006/main">
+  <p:cSld name="Slide 22">
     <p:bg>
       <p:bgPr>
         <a:blipFill dpi="0" rotWithShape="1">

</xml_diff>

<commit_message>
polish: final pre-lecture sweep
- Delete tracked extensionless build artifact
  lecture/agentic-ai-for-lead-generation (263 KB stale HTML with the
  old 'Marketing Chair' footer — leftover from a mis-suffixed -o
  rebuild loop). Disk and git are clean now.
- Roadmap honesty note told a false pacing story: claimed notes sum
  to ~32 min, real sum is ~36.75 (~37) — slightly OVER the 35-min
  budget, not under. Note now says so and names the flex (Step 2's
  ~8 min estimate is padded; T1 finished well inside it) plus the
  if-behind cuts (trim Define-the-hunt, Providers to the HRZ line,
  skip DNS aside unless it bites).
- Take-aways blockquote no longer hard-breaks mid-sentence
  ('…feeds into / the Bachelor course…') — one flowing line,
  deslopped: 'the chair decides what this feeds: the Bachelor
  course "Sales Strategy and Execution".'

Rebuilt html/pdf/pptx: 22 pages, 0 overflow, 0 leaks, footer
clearance ≥44px on all slides; tests 19/19; both lead validators
pass.
</commit_message>
<xml_diff>
--- a/lecture/agentic-ai-for-lead-generation.pptx
+++ b/lecture/agentic-ai-for-lead-generation.pptx
@@ -2189,11 +2189,14 @@
 the method, then the live walkthrough — the heart — and a short
 reflection at the end. Ten minutes are reserved for your questions.
 If one comes to you mid-talk, write it down — we'll get to it.
-[Not read:] The notes sum to ~32 min; the gap to 35 is deliberate
-buffer for transitions and demo hiccups. Q&amp;A is fixed at 10 min —
-bank questions with "hold that for Q&amp;A". The BrowserMCP intermezzo
-inside Step 2 (~45 s: why a real browser — LinkedIn, consent walls,
-logins) folds into the walkthrough buffer.</a:t>
+[Not read:] The notes sum to ~37 min — slightly over the 35 budget.
+The flex is Step 2: its ~8 min estimate is padded; in the T1 run the
+agent finished well inside it. If running behind: trim Define-the-
+hunt (45 s), compress Providers to the HRZ line, skip the DNS aside
+unless it bites. Q&amp;A is fixed at 10 min — bank questions with
+"hold that for Q&amp;A". The BrowserMCP intermezzo inside Step 2 (~45 s:
+why a real browser — LinkedIn, consent walls, logins) folds into
+the walkthrough buffer.</a:t>
             </a:r>
             <a:endParaRPr lang="en-US" dirty="0"/>
           </a:p>

</xml_diff>

<commit_message>
lecture slide 7: add Beam Free + privacy caution (train-on-input)
OpenCode Zen lists free models alongside the HRZ API. Beam Free
(Reflection's open-weight 501B MoE, Apache 2.0, 1M-token context)
joins Big Pickle as a no-cost option — with a privacy edge: Beam
Free's provider does not train on user input (30-day retention for
safety), while Big Pickle is a stealth model whose provider may
train on it.

New row in the providers table; on-slide blockquote now carries
the privacy rule: never paste private, customer, or unpublished
data into a model that trains on user input — for sensitive work
use HRZ (local, JLU) or Ollama. The DNS fix (172.65.90.20) moves
to the speaker notes (already there) to make room; on-slide
blockquote keeps the start-with-HRZ pointer.

Table compressed (6 rows fit; content bottom y=629 vs footer
y=682, +53px). Narration updated. Rebuilt html/pdf/pptx: 22
pages, 0 overflow, 0 leaks, footer clearance ≥44px all slides.
</commit_message>
<xml_diff>
--- a/lecture/agentic-ai-for-lead-generation.pptx
+++ b/lecture/agentic-ai-for-lead-generation.pptx
@@ -2489,13 +2489,19 @@
 first: the JLU HRZ API-Service. Free LLMs for every university
 member — locally hosted Qwen models with up to a million tokens of
 context, plus commercial models. Access by emailing
-ki@uni-giessen.de; works with OpenCode out of the box. Google gives
-students a year of Google AI Plus free — verify with your
-university email by the end of December. OpenRouter: one key, many
-models, free tiers included. Ollama runs locally — free and
-private. And the harnesses — OpenCode and pi — are the tools
-behind today's live demo. If you take one thing from this slide:
-start with HRZ.
+ki@uni-giessen.de; works with OpenCode out of the box. Second,
+OpenCode Zen lists free models — Big Pickle (a stealth model, free
+for now) and Beam Free (Reflection's open-weight 501-billion model,
+also free, with a one-million-token context). One privacy caveat:
+Big Pickle's provider may train on your input; Beam Free and the
+HRZ local models do not. So never paste private, customer, or
+unpublished research data into a model that trains on user input —
+for sensitive work, use HRZ or run Ollama on your own laptop.
+Google gives students a year of Google AI Plus free — verify with
+your university email by the end of December. OpenRouter: one key,
+many models, free tiers included. And the harnesses — OpenCode and
+pi — are the tools behind today's live demo. If you take one thing
+from this slide: start with HRZ.
 One practical note on the network: if the campus Wi-Fi cannot
 resolve opencode.ai, the fix — a public resolver or a hosts entry —
 is in the HRZ one-pager. Thirty seconds of setup, then move on.

</xml_diff>